<commit_message>
docs: unify presentation around technical workflow
</commit_message>
<xml_diff>
--- a/output/pptx/learnenergy-foundations-technical-report-cn-v2.pptx
+++ b/output/pptx/learnenergy-foundations-technical-report-cn-v2.pptx
@@ -375,7 +375,7 @@
             <a:pPr/>
             <a:r>
               <a:rPr lang="zh-CN" dirty="0"/>
-              <a:t>本报告介绍 learnenergy 的统计模型、计算方法与软件封装。项目关注的不是单个变量的孤立预测，而是资源、支持、成绩等多个变量共同出现的概率结构。报告依次覆盖联合分布、能量模型、训练方法、解释诊断、论文复现和 package 调用。</a:t>
+              <a:t>本报告介绍 learnenergy 的统计模型、计算方法与软件封装。项目关注的不是单个变量的孤立预测，而是资源、支持、成绩等多个变量共同出现的概率结构。全篇沿统一技术链推进：概率表示、模型定义、计算与训练、解释与诊断、连续模型扩展、Package 实现和复现验证。</a:t>
             </a:r>
           </a:p>
         </p:txBody>
@@ -615,7 +615,7 @@
             <a:pPr/>
             <a:r>
               <a:rPr lang="zh-CN" dirty="0"/>
-              <a:t>预处理决定节点状态的实际语义。一般使用可以按中位数划分；论文复现则在每个 repeat 内执行 z-score，并采用严格的 z 大于一作为阈值。中心、尺度、阈值、缺失值策略和列顺序都必须随模型保存。</a:t>
+              <a:t>预处理决定节点状态的实际语义。一般使用可以按中位数划分；论文复现则在每个 repeat 内执行 z-score，并采用严格的 z 大于一作为阈值。中心、尺度、阈值、缺失值策略和列顺序都必须随模型保存。本阶段的输出是可计算的二值状态矩阵和预处理契约，下一阶段据此选择计算路径和训练方法。</a:t>
             </a:r>
           </a:p>
         </p:txBody>
@@ -1035,7 +1035,7 @@
             <a:pPr/>
             <a:r>
               <a:rPr lang="zh-CN" dirty="0"/>
-              <a:t>learnenergy 包含两类联合分布模型。二值数据由 LearningModel 建模，核心是 pairwise maximum-entropy；连续数据由 ContinuousEnergyModel 建模，核心是 Gaussian quadratic energy。两类模型共享拟合、诊断、解释和模型持久化的工作流。</a:t>
+              <a:t>全篇只沿一条技术链推进。第一阶段建立联合、边缘与条件概率的表示语言；第二阶段把状态空间写成能量函数、概率分布与 moments 约束；第三阶段选择 exact 或 Monte Carlo 计算模型 moments，并用 moment matching、KL 或 Adam 更新参数；第四阶段在收敛和采样质量通过后解释参数及敏感性；第五阶段把同一联合建模思想扩展到连续 Gaussian 模型；第六阶段将配置、训练、诊断与保存固化为 package 接口；第七阶段以 PISA 复现实验检验整条链。后续页眉中的阶段编号与本页完全对应。</a:t>
             </a:r>
           </a:p>
         </p:txBody>
@@ -1095,7 +1095,7 @@
             <a:pPr/>
             <a:r>
               <a:rPr lang="zh-CN" dirty="0"/>
-              <a:t>calculation 决定模型 moments 的计算方式，method 决定参数更新方式。小规模与数值验证可使用 exact 配合 KL 或 moment matching；更大规模使用 Monte Carlo 配合 moment matching；对齐公开代码更新结构时使用 Monte Carlo 配合 Adam。科研报告应记录最终实际路径，而非只记录 auto。</a:t>
+              <a:t>calculation 决定模型 moments 的计算方式，method 决定参数更新方式。小规模与数值验证可使用 exact 配合 KL 或 moment matching；更大规模使用 Monte Carlo 配合 moment matching；对齐公开代码更新结构时使用 Monte Carlo 配合 Adam。科研报告应记录最终实际路径，而非只记录 auto。本阶段的输出是训练配置、拟合参数与收敛证据，下一阶段在这些前提下解释模型。</a:t>
             </a:r>
           </a:p>
         </p:txBody>
@@ -1215,7 +1215,7 @@
             <a:pPr/>
             <a:r>
               <a:rPr lang="zh-CN" dirty="0"/>
-              <a:t>温度 T 通过能量除以 T 重新缩放整个模型分布。低温使概率集中于低能量状态，高温使分布更平坦。平均能量或 magnetization 对温度导数的峰值表示模型的高敏感区域，但不自动对应现实系统中的物理相变。</a:t>
+              <a:t>温度 T 通过能量除以 T 重新缩放整个模型分布。低温使概率集中于低能量状态，高温使分布更平坦。平均能量或 magnetization 对温度导数的峰值表示模型的高敏感区域，但不自动对应现实系统中的物理相变。本阶段输出模型内解释及其边界；下一阶段保持联合建模框架，但把状态空间扩展为连续变量。</a:t>
             </a:r>
           </a:p>
         </p:txBody>
@@ -1395,7 +1395,7 @@
             <a:pPr/>
             <a:r>
               <a:rPr lang="zh-CN" dirty="0"/>
-              <a:t>ContinuousEnergyModel 在训练时联合拟合全部变量，不固定 target_name。调用 conditional_mean 时通过 target_index 选择当前查询变量，并根据其他已知变量计算条件期望。sample 方法从完整联合 Gaussian 分布生成样本；当前实现不覆盖非线性、重尾或混合节点分布。</a:t>
+              <a:t>ContinuousEnergyModel 在训练时联合拟合全部变量，不固定 target_name。调用 conditional_mean 时通过 target_index 选择当前查询变量，并根据其他已知变量计算条件期望。sample 方法从完整联合 Gaussian 分布生成样本；当前实现不覆盖非线性、重尾或混合节点分布。本阶段输出连续联合模型和条件查询语义，下一阶段将二值与连续路径统一到 package 接口。</a:t>
             </a:r>
           </a:p>
         </p:txBody>
@@ -1575,7 +1575,7 @@
             <a:pPr/>
             <a:r>
               <a:rPr lang="zh-CN" dirty="0"/>
-              <a:t>连续模型以所有联合变量名称初始化，并通过 ridge 控制协方差正则。fit 接受连续数据矩阵；conditional_mean 通过 target_index 查询指定变量；sample 生成联合模拟数据。该接口适合连续、近似单峰和线性条件关系的数据。</a:t>
+              <a:t>连续模型以所有联合变量名称初始化，并通过 ridge 控制协方差正则。fit 接受连续数据矩阵；conditional_mean 通过 target_index 查询指定变量；sample 生成联合模拟数据。该接口适合连续、近似单峰和线性条件关系的数据。本阶段输出可复用调用方式与模型 artifact，下一阶段用论文复现实验检查整条实现链。</a:t>
             </a:r>
           </a:p>
         </p:txBody>
@@ -1755,7 +1755,7 @@
             <a:pPr/>
             <a:r>
               <a:rPr lang="zh-CN" dirty="0"/>
-              <a:t>完整流程包括定义变量与状态空间、选择 exact 或 Monte Carlo、选择训练更新方法、验证 moments 与诊断指标、解释结果并保存模型 artifact。二值模型描述状态组合概率与 pairwise 结构，连续模型描述连续变量共同变化与条件均值。所有解释均以训练收敛、采样质量和复现验证通过为前提。</a:t>
+              <a:t>完整技术链由七个阶段组成：概率表示、模型定义、计算与训练、解释与诊断、连续模型扩展、Package 实现和复现验证。二值模型描述状态组合概率与 pairwise 结构，连续模型描述连续变量共同变化与条件均值。模型 artifact 固化参数、预处理、诊断与版本信息。所有解释均以训练收敛、采样质量和复现验证通过为前提。</a:t>
             </a:r>
           </a:p>
         </p:txBody>
@@ -1875,7 +1875,7 @@
             <a:pPr/>
             <a:r>
               <a:rPr lang="zh-CN" dirty="0"/>
-              <a:t>相关性只描述两个量共同变化，不能区分直接关系与共同关联。条件依赖进一步描述在其他节点给定后的剩余统计关系。因果结论还需要实验设计或额外识别假设，因此模型参数 J 和节点冻结结果都限定为拟合分布内部的解释。</a:t>
+              <a:t>相关性只描述两个量共同变化，不能区分直接关系与共同关联。条件依赖进一步描述在其他节点给定后的剩余统计关系。因果结论还需要实验设计或额外识别假设，因此模型参数 J 和节点冻结结果都限定为拟合分布内部的解释。本阶段的输出是概率关系语言和解释边界，下一阶段据此定义能量模型。</a:t>
             </a:r>
           </a:p>
         </p:txBody>
@@ -2652,9 +2652,9 @@
         <p:grpSpPr>
           <a:xfrm>
             <a:off x="592074" y="643414"/>
-            <a:ext cx="6516800" cy="1971770"/>
+            <a:ext cx="5781675" cy="1971770"/>
             <a:chOff x="592074" y="643414"/>
-            <a:chExt cx="6516800" cy="1971770"/>
+            <a:chExt cx="5781675" cy="1971770"/>
           </a:xfrm>
         </p:grpSpPr>
         <p:sp>
@@ -2786,7 +2786,7 @@
           <p:spPr>
             <a:xfrm>
               <a:off x="600456" y="2263140"/>
-              <a:ext cx="6508418" cy="352044"/>
+              <a:ext cx="5773293" cy="352044"/>
             </a:xfrm>
             <a:prstGeom prst="rect">
               <a:avLst/>
@@ -2812,7 +2812,7 @@
                   <a:ea typeface="+mn-ea"/>
                   <a:cs typeface="+mn-cs"/>
                 </a:rPr>
-                <a:t>从概率基础到可解释能量模型，再到可复用 Python package</a:t>
+                <a:t>统一技术链：表示 → 定义 → 训练 → 解释 → 实现 → 验证</a:t>
               </a:r>
             </a:p>
           </p:txBody>
@@ -3238,9 +3238,9 @@
         <p:grpSpPr>
           <a:xfrm>
             <a:off x="677418" y="5334000"/>
-            <a:ext cx="10464080" cy="594551"/>
+            <a:ext cx="10371582" cy="594551"/>
             <a:chOff x="677418" y="5334000"/>
-            <a:chExt cx="10464080" cy="594551"/>
+            <a:chExt cx="10371582" cy="594551"/>
           </a:xfrm>
         </p:grpSpPr>
         <p:sp>
@@ -3424,7 +3424,7 @@
                   <a:ea typeface="+mn-ea"/>
                   <a:cs typeface="+mn-cs"/>
                 </a:rPr>
-                <a:t>联合分布</a:t>
+                <a:t>概率表示</a:t>
               </a:r>
             </a:p>
           </p:txBody>
@@ -3464,7 +3464,7 @@
                   <a:ea typeface="+mn-ea"/>
                   <a:cs typeface="+mn-cs"/>
                 </a:rPr>
-                <a:t>能量模型</a:t>
+                <a:t>模型定义</a:t>
               </a:r>
             </a:p>
           </p:txBody>
@@ -3504,7 +3504,7 @@
                   <a:ea typeface="+mn-ea"/>
                   <a:cs typeface="+mn-cs"/>
                 </a:rPr>
-                <a:t>训练方法</a:t>
+                <a:t>计算训练</a:t>
               </a:r>
             </a:p>
           </p:txBody>
@@ -3517,8 +3517,8 @@
           </p:nvSpPr>
           <p:spPr>
             <a:xfrm>
-              <a:off x="7730299" y="5664518"/>
-              <a:ext cx="922401" cy="264033"/>
+              <a:off x="7821168" y="5664518"/>
+              <a:ext cx="740664" cy="264033"/>
             </a:xfrm>
             <a:prstGeom prst="rect">
               <a:avLst/>
@@ -3544,7 +3544,7 @@
                   <a:ea typeface="+mn-ea"/>
                   <a:cs typeface="+mn-cs"/>
                 </a:rPr>
-                <a:t>解释与验证</a:t>
+                <a:t>解释诊断</a:t>
               </a:r>
             </a:p>
           </p:txBody>
@@ -3557,8 +3557,8 @@
           </p:nvSpPr>
           <p:spPr>
             <a:xfrm>
-              <a:off x="10004001" y="5664518"/>
-              <a:ext cx="1137497" cy="264033"/>
+              <a:off x="10202418" y="5664518"/>
+              <a:ext cx="740664" cy="264033"/>
             </a:xfrm>
             <a:prstGeom prst="rect">
               <a:avLst/>
@@ -3584,7 +3584,7 @@
                   <a:ea typeface="+mn-ea"/>
                   <a:cs typeface="+mn-cs"/>
                 </a:rPr>
-                <a:t>Package 调用</a:t>
+                <a:t>实现验证</a:t>
               </a:r>
             </a:p>
           </p:txBody>
@@ -3689,7 +3689,7 @@
           <p:spPr>
             <a:xfrm>
               <a:off x="603504" y="556260"/>
-              <a:ext cx="1328776" cy="234696"/>
+              <a:ext cx="1716481" cy="234696"/>
             </a:xfrm>
             <a:prstGeom prst="rect">
               <a:avLst/>
@@ -3715,7 +3715,7 @@
                   <a:ea typeface="+mn-ea"/>
                   <a:cs typeface="+mn-cs"/>
                 </a:rPr>
-                <a:t>二值模型 · 归一化</a:t>
+                <a:t>技术主线 · 02 模型定义</a:t>
               </a:r>
             </a:p>
           </p:txBody>
@@ -4851,7 +4851,7 @@
           <p:spPr>
             <a:xfrm>
               <a:off x="603504" y="556260"/>
-              <a:ext cx="1537760" cy="234696"/>
+              <a:ext cx="1716481" cy="234696"/>
             </a:xfrm>
             <a:prstGeom prst="rect">
               <a:avLst/>
@@ -4877,7 +4877,7 @@
                   <a:ea typeface="+mn-ea"/>
                   <a:cs typeface="+mn-cs"/>
                 </a:rPr>
-                <a:t>训练目标 · Moments</a:t>
+                <a:t>技术主线 · 02 模型定义</a:t>
               </a:r>
             </a:p>
           </p:txBody>
@@ -5889,7 +5889,7 @@
           <p:spPr>
             <a:xfrm>
               <a:off x="603504" y="556260"/>
-              <a:ext cx="1490320" cy="234696"/>
+              <a:ext cx="1716481" cy="234696"/>
             </a:xfrm>
             <a:prstGeom prst="rect">
               <a:avLst/>
@@ -5915,7 +5915,7 @@
                   <a:ea typeface="+mn-ea"/>
                   <a:cs typeface="+mn-cs"/>
                 </a:rPr>
-                <a:t>联合模型 · 条件预测</a:t>
+                <a:t>技术主线 · 02 模型定义</a:t>
               </a:r>
             </a:p>
           </p:txBody>
@@ -6691,7 +6691,7 @@
           <p:spPr>
             <a:xfrm>
               <a:off x="603504" y="556260"/>
-              <a:ext cx="1328776" cy="234696"/>
+              <a:ext cx="1716481" cy="234696"/>
             </a:xfrm>
             <a:prstGeom prst="rect">
               <a:avLst/>
@@ -6717,7 +6717,7 @@
                   <a:ea typeface="+mn-ea"/>
                   <a:cs typeface="+mn-cs"/>
                 </a:rPr>
-                <a:t>数据语义 · 预处理</a:t>
+                <a:t>技术主线 · 02 模型定义</a:t>
               </a:r>
             </a:p>
           </p:txBody>
@@ -7679,7 +7679,7 @@
         <p:spPr>
           <a:xfrm>
             <a:off x="604266" y="6516052"/>
-            <a:ext cx="3473768" cy="205359"/>
+            <a:ext cx="4152252" cy="205359"/>
           </a:xfrm>
           <a:prstGeom prst="rect">
             <a:avLst/>
@@ -7705,7 +7705,7 @@
                 <a:ea typeface="+mn-ea"/>
                 <a:cs typeface="+mn-cs"/>
               </a:rPr>
-              <a:t>13 / 30 · 中心、尺度、阈值和列顺序都必须随模型保存</a:t>
+              <a:t>本阶段输出：二值状态矩阵 + 预处理契约 → 下一阶段：计算与训练</a:t>
             </a:r>
           </a:p>
         </p:txBody>
@@ -7769,7 +7769,7 @@
           <p:spPr>
             <a:xfrm>
               <a:off x="603504" y="556260"/>
-              <a:ext cx="1324051" cy="234696"/>
+              <a:ext cx="1878025" cy="234696"/>
             </a:xfrm>
             <a:prstGeom prst="rect">
               <a:avLst/>
@@ -7795,7 +7795,7 @@
                   <a:ea typeface="+mn-ea"/>
                   <a:cs typeface="+mn-cs"/>
                 </a:rPr>
-                <a:t>计算路径 · EXACT</a:t>
+                <a:t>技术主线 · 03 计算与训练</a:t>
               </a:r>
             </a:p>
           </p:txBody>
@@ -9302,7 +9302,7 @@
           <p:spPr>
             <a:xfrm>
               <a:off x="603504" y="556260"/>
-              <a:ext cx="1947062" cy="234696"/>
+              <a:ext cx="1878025" cy="234696"/>
             </a:xfrm>
             <a:prstGeom prst="rect">
               <a:avLst/>
@@ -9328,7 +9328,7 @@
                   <a:ea typeface="+mn-ea"/>
                   <a:cs typeface="+mn-cs"/>
                 </a:rPr>
-                <a:t>计算路径 · MONTE CARLO</a:t>
+                <a:t>技术主线 · 03 计算与训练</a:t>
               </a:r>
             </a:p>
           </p:txBody>
@@ -10714,7 +10714,7 @@
           <p:spPr>
             <a:xfrm>
               <a:off x="603504" y="556260"/>
-              <a:ext cx="1836115" cy="234696"/>
+              <a:ext cx="1878025" cy="234696"/>
             </a:xfrm>
             <a:prstGeom prst="rect">
               <a:avLst/>
@@ -10740,7 +10740,7 @@
                   <a:ea typeface="+mn-ea"/>
                   <a:cs typeface="+mn-cs"/>
                 </a:rPr>
-                <a:t>采样质量 · DIAGNOSTICS</a:t>
+                <a:t>技术主线 · 03 计算与训练</a:t>
               </a:r>
             </a:p>
           </p:txBody>
@@ -11948,7 +11948,7 @@
           <p:spPr>
             <a:xfrm>
               <a:off x="603504" y="556260"/>
-              <a:ext cx="2314042" cy="234696"/>
+              <a:ext cx="1878025" cy="234696"/>
             </a:xfrm>
             <a:prstGeom prst="rect">
               <a:avLst/>
@@ -11974,7 +11974,7 @@
                   <a:ea typeface="+mn-ea"/>
                   <a:cs typeface="+mn-cs"/>
                 </a:rPr>
-                <a:t>训练方法 · MOMENT MATCHING</a:t>
+                <a:t>技术主线 · 03 计算与训练</a:t>
               </a:r>
             </a:p>
           </p:txBody>
@@ -13481,7 +13481,7 @@
           <p:spPr>
             <a:xfrm>
               <a:off x="603504" y="556260"/>
-              <a:ext cx="1989734" cy="234696"/>
+              <a:ext cx="1878025" cy="234696"/>
             </a:xfrm>
             <a:prstGeom prst="rect">
               <a:avLst/>
@@ -13507,7 +13507,7 @@
                   <a:ea typeface="+mn-ea"/>
                   <a:cs typeface="+mn-cs"/>
                 </a:rPr>
-                <a:t>训练方法 · KL DIVERGENCE</a:t>
+                <a:t>技术主线 · 03 计算与训练</a:t>
               </a:r>
             </a:p>
           </p:txBody>
@@ -14996,7 +14996,7 @@
           <p:spPr>
             <a:xfrm>
               <a:off x="603504" y="556260"/>
-              <a:ext cx="1264310" cy="234696"/>
+              <a:ext cx="1878025" cy="234696"/>
             </a:xfrm>
             <a:prstGeom prst="rect">
               <a:avLst/>
@@ -15022,7 +15022,7 @@
                   <a:ea typeface="+mn-ea"/>
                   <a:cs typeface="+mn-cs"/>
                 </a:rPr>
-                <a:t>训练方法 · ADAM</a:t>
+                <a:t>技术主线 · 03 计算与训练</a:t>
               </a:r>
             </a:p>
           </p:txBody>
@@ -16436,16 +16436,16 @@
       </p:grpSpPr>
       <p:grpSp>
         <p:nvGrpSpPr>
-          <p:cNvPr id="4" name="p02-header"/>
+          <p:cNvPr id="5" name="p02-header"/>
           <p:cNvGrpSpPr/>
           <p:nvPr/>
         </p:nvGrpSpPr>
         <p:grpSpPr>
           <a:xfrm>
             <a:off x="593598" y="556260"/>
-            <a:ext cx="3616452" cy="881825"/>
+            <a:ext cx="6752844" cy="1009841"/>
             <a:chOff x="593598" y="556260"/>
-            <a:chExt cx="3616452" cy="881825"/>
+            <a:chExt cx="6752844" cy="1009841"/>
           </a:xfrm>
         </p:grpSpPr>
         <p:sp>
@@ -16457,7 +16457,7 @@
           <p:spPr>
             <a:xfrm>
               <a:off x="603504" y="556260"/>
-              <a:ext cx="658368" cy="234696"/>
+              <a:ext cx="1554937" cy="234696"/>
             </a:xfrm>
             <a:prstGeom prst="rect">
               <a:avLst/>
@@ -16483,7 +16483,7 @@
                   <a:ea typeface="+mn-ea"/>
                   <a:cs typeface="+mn-cs"/>
                 </a:rPr>
-                <a:t>模型体系</a:t>
+                <a:t>技术主线 · 00 全流程</a:t>
               </a:r>
             </a:p>
           </p:txBody>
@@ -16497,7 +16497,7 @@
           <p:spPr>
             <a:xfrm>
               <a:off x="593598" y="822008"/>
-              <a:ext cx="3616452" cy="616077"/>
+              <a:ext cx="6752844" cy="616077"/>
             </a:xfrm>
             <a:prstGeom prst="rect">
               <a:avLst/>
@@ -16523,7 +16523,47 @@
                   <a:ea typeface="+mj-ea"/>
                   <a:cs typeface="+mj-cs"/>
                 </a:rPr>
-                <a:t>模型族与统一接口</a:t>
+                <a:t>从数据到可复用模型的完整技术链</a:t>
+              </a:r>
+            </a:p>
+          </p:txBody>
+        </p:sp>
+        <p:sp>
+          <p:nvSpPr>
+            <p:cNvPr id="4" name="TextBox 4"/>
+            <p:cNvSpPr txBox="1"/>
+            <p:nvPr/>
+          </p:nvSpPr>
+          <p:spPr>
+            <a:xfrm>
+              <a:off x="602742" y="1302068"/>
+              <a:ext cx="5829300" cy="264033"/>
+            </a:xfrm>
+            <a:prstGeom prst="rect">
+              <a:avLst/>
+            </a:prstGeom>
+            <a:noFill/>
+            <a:ln>
+              <a:noFill/>
+            </a:ln>
+          </p:spPr>
+          <p:txBody>
+            <a:bodyPr wrap="none" lIns="0" tIns="0" rIns="0" bIns="0" anchor="t" anchorCtr="0">
+              <a:spAutoFit/>
+            </a:bodyPr>
+            <a:lstStyle/>
+            <a:p>
+              <a:pPr algn="l"/>
+              <a:r>
+                <a:rPr lang="zh-CN" sz="1350" dirty="0">
+                  <a:solidFill>
+                    <a:schemeClr val="accent5"/>
+                  </a:solidFill>
+                  <a:latin typeface="+mn-lt"/>
+                  <a:ea typeface="+mn-ea"/>
+                  <a:cs typeface="+mn-cs"/>
+                </a:rPr>
+                <a:t>每个阶段的输出，直接成为下一阶段的输入；后续页面按同一编号展开。</a:t>
               </a:r>
             </a:p>
           </p:txBody>
@@ -16531,414 +16571,32 @@
       </p:grpSp>
       <p:grpSp>
         <p:nvGrpSpPr>
-          <p:cNvPr id="27" name="p02-map"/>
+          <p:cNvPr id="36" name="p02-row-one"/>
           <p:cNvGrpSpPr/>
           <p:nvPr/>
         </p:nvGrpSpPr>
         <p:grpSpPr>
           <a:xfrm>
-            <a:off x="800100" y="1562100"/>
-            <a:ext cx="10591800" cy="4419600"/>
-            <a:chOff x="800100" y="1562100"/>
-            <a:chExt cx="10591800" cy="4419600"/>
+            <a:off x="609600" y="1885950"/>
+            <a:ext cx="10972800" cy="1409700"/>
+            <a:chOff x="609600" y="1885950"/>
+            <a:chExt cx="10972800" cy="1409700"/>
           </a:xfrm>
         </p:grpSpPr>
         <p:sp>
           <p:nvSpPr>
-            <p:cNvPr id="5" name="Rectangle 5"/>
+            <p:cNvPr id="6" name="Rectangle 6"/>
             <p:cNvSpPr/>
             <p:nvPr/>
           </p:nvSpPr>
           <p:spPr>
             <a:xfrm>
-              <a:off x="4533900" y="1562100"/>
-              <a:ext cx="3124200" cy="742950"/>
+              <a:off x="609600" y="1885950"/>
+              <a:ext cx="2381250" cy="1409700"/>
             </a:xfrm>
             <a:prstGeom prst="roundRect">
               <a:avLst>
-                <a:gd name="adj" fmla="val 50000"/>
-              </a:avLst>
-            </a:prstGeom>
-            <a:solidFill>
-              <a:schemeClr val="accent1"/>
-            </a:solidFill>
-            <a:ln>
-              <a:noFill/>
-            </a:ln>
-          </p:spPr>
-        </p:sp>
-        <p:sp>
-          <p:nvSpPr>
-            <p:cNvPr id="6" name="TextBox 6"/>
-            <p:cNvSpPr txBox="1"/>
-            <p:nvPr/>
-          </p:nvSpPr>
-          <p:spPr>
-            <a:xfrm>
-              <a:off x="4590085" y="1810226"/>
-              <a:ext cx="3011830" cy="396050"/>
-            </a:xfrm>
-            <a:prstGeom prst="rect">
-              <a:avLst/>
-            </a:prstGeom>
-            <a:noFill/>
-            <a:ln>
-              <a:noFill/>
-            </a:ln>
-          </p:spPr>
-          <p:txBody>
-            <a:bodyPr wrap="none" lIns="0" tIns="0" rIns="0" bIns="0" anchor="t" anchorCtr="0">
-              <a:spAutoFit/>
-            </a:bodyPr>
-            <a:lstStyle/>
-            <a:p>
-              <a:pPr algn="ctr"/>
-              <a:r>
-                <a:rPr lang="zh-CN" sz="2020" dirty="0">
-                  <a:solidFill>
-                    <a:srgbClr val="FFFFFF"/>
-                  </a:solidFill>
-                  <a:latin typeface="+mn-lt"/>
-                  <a:ea typeface="+mn-ea"/>
-                  <a:cs typeface="+mn-cs"/>
-                </a:rPr>
-                <a:t>学习多个变量的联合分布</a:t>
-              </a:r>
-            </a:p>
-          </p:txBody>
-        </p:sp>
-        <p:sp>
-          <p:nvSpPr>
-            <p:cNvPr id="7" name="Line 7"/>
-            <p:cNvSpPr/>
-            <p:nvPr/>
-          </p:nvSpPr>
-          <p:spPr>
-            <a:xfrm>
-              <a:off x="3467100" y="2305050"/>
-              <a:ext cx="2628900" cy="647700"/>
-            </a:xfrm>
-            <a:custGeom>
-              <a:avLst/>
-              <a:gdLst/>
-              <a:ahLst/>
-              <a:cxnLst/>
-              <a:rect l="l" t="t" r="r" b="b"/>
-              <a:pathLst>
-                <a:path w="2628900" h="647700">
-                  <a:moveTo>
-                    <a:pt x="2628900" y="0"/>
-                  </a:moveTo>
-                  <a:lnTo>
-                    <a:pt x="0" y="647700"/>
-                  </a:lnTo>
-                </a:path>
-              </a:pathLst>
-            </a:custGeom>
-            <a:noFill/>
-            <a:ln w="38100">
-              <a:solidFill>
-                <a:schemeClr val="accent6"/>
-              </a:solidFill>
-            </a:ln>
-          </p:spPr>
-        </p:sp>
-        <p:sp>
-          <p:nvSpPr>
-            <p:cNvPr id="8" name="Line 8"/>
-            <p:cNvSpPr/>
-            <p:nvPr/>
-          </p:nvSpPr>
-          <p:spPr>
-            <a:xfrm>
-              <a:off x="6096000" y="2305050"/>
-              <a:ext cx="2628900" cy="647700"/>
-            </a:xfrm>
-            <a:custGeom>
-              <a:avLst/>
-              <a:gdLst/>
-              <a:ahLst/>
-              <a:cxnLst/>
-              <a:rect l="l" t="t" r="r" b="b"/>
-              <a:pathLst>
-                <a:path w="2628900" h="647700">
-                  <a:moveTo>
-                    <a:pt x="0" y="0"/>
-                  </a:moveTo>
-                  <a:lnTo>
-                    <a:pt x="2628900" y="647700"/>
-                  </a:lnTo>
-                </a:path>
-              </a:pathLst>
-            </a:custGeom>
-            <a:noFill/>
-            <a:ln w="38100">
-              <a:solidFill>
-                <a:schemeClr val="accent6"/>
-              </a:solidFill>
-            </a:ln>
-          </p:spPr>
-        </p:sp>
-        <p:sp>
-          <p:nvSpPr>
-            <p:cNvPr id="9" name="Rectangle 9"/>
-            <p:cNvSpPr/>
-            <p:nvPr/>
-          </p:nvSpPr>
-          <p:spPr>
-            <a:xfrm>
-              <a:off x="800100" y="2952750"/>
-              <a:ext cx="4857750" cy="2019300"/>
-            </a:xfrm>
-            <a:prstGeom prst="roundRect">
-              <a:avLst>
-                <a:gd name="adj" fmla="val 8491"/>
-              </a:avLst>
-            </a:prstGeom>
-            <a:solidFill>
-              <a:schemeClr val="lt2"/>
-            </a:solidFill>
-            <a:ln>
-              <a:noFill/>
-            </a:ln>
-          </p:spPr>
-        </p:sp>
-        <p:sp>
-          <p:nvSpPr>
-            <p:cNvPr id="10" name="Ellipse 10"/>
-            <p:cNvSpPr/>
-            <p:nvPr/>
-          </p:nvSpPr>
-          <p:spPr>
-            <a:xfrm>
-              <a:off x="1028700" y="3200400"/>
-              <a:ext cx="647700" cy="647700"/>
-            </a:xfrm>
-            <a:prstGeom prst="ellipse">
-              <a:avLst/>
-            </a:prstGeom>
-            <a:solidFill>
-              <a:schemeClr val="accent2"/>
-            </a:solidFill>
-            <a:ln>
-              <a:noFill/>
-            </a:ln>
-          </p:spPr>
-        </p:sp>
-        <p:sp>
-          <p:nvSpPr>
-            <p:cNvPr id="11" name="TextBox 11"/>
-            <p:cNvSpPr txBox="1"/>
-            <p:nvPr/>
-          </p:nvSpPr>
-          <p:spPr>
-            <a:xfrm>
-              <a:off x="1143495" y="3406140"/>
-              <a:ext cx="418109" cy="352044"/>
-            </a:xfrm>
-            <a:prstGeom prst="rect">
-              <a:avLst/>
-            </a:prstGeom>
-            <a:noFill/>
-            <a:ln>
-              <a:noFill/>
-            </a:ln>
-          </p:spPr>
-          <p:txBody>
-            <a:bodyPr wrap="none" lIns="0" tIns="0" rIns="0" bIns="0" anchor="t" anchorCtr="0">
-              <a:spAutoFit/>
-            </a:bodyPr>
-            <a:lstStyle/>
-            <a:p>
-              <a:pPr algn="ctr"/>
-              <a:r>
-                <a:rPr lang="zh-CN" sz="1800" dirty="0">
-                  <a:solidFill>
-                    <a:srgbClr val="FFFFFF"/>
-                  </a:solidFill>
-                  <a:latin typeface="Consolas"/>
-                  <a:ea typeface="Consolas"/>
-                  <a:cs typeface="Consolas"/>
-                </a:rPr>
-                <a:t>0/1</a:t>
-              </a:r>
-            </a:p>
-          </p:txBody>
-        </p:sp>
-        <p:sp>
-          <p:nvSpPr>
-            <p:cNvPr id="12" name="TextBox 12"/>
-            <p:cNvSpPr txBox="1"/>
-            <p:nvPr/>
-          </p:nvSpPr>
-          <p:spPr>
-            <a:xfrm>
-              <a:off x="1855470" y="3186112"/>
-              <a:ext cx="2287407" cy="440055"/>
-            </a:xfrm>
-            <a:prstGeom prst="rect">
-              <a:avLst/>
-            </a:prstGeom>
-            <a:noFill/>
-            <a:ln>
-              <a:noFill/>
-            </a:ln>
-          </p:spPr>
-          <p:txBody>
-            <a:bodyPr wrap="none" lIns="0" tIns="0" rIns="0" bIns="0" anchor="t" anchorCtr="0">
-              <a:spAutoFit/>
-            </a:bodyPr>
-            <a:lstStyle/>
-            <a:p>
-              <a:pPr algn="l"/>
-              <a:r>
-                <a:rPr lang="en-US" sz="2250" dirty="0">
-                  <a:solidFill>
-                    <a:schemeClr val="accent1"/>
-                  </a:solidFill>
-                  <a:latin typeface="+mj-lt"/>
-                  <a:ea typeface="+mj-ea"/>
-                  <a:cs typeface="+mj-cs"/>
-                </a:rPr>
-                <a:t>LearningModel</a:t>
-              </a:r>
-            </a:p>
-          </p:txBody>
-        </p:sp>
-        <p:sp>
-          <p:nvSpPr>
-            <p:cNvPr id="13" name="TextBox 13"/>
-            <p:cNvSpPr txBox="1"/>
-            <p:nvPr/>
-          </p:nvSpPr>
-          <p:spPr>
-            <a:xfrm>
-              <a:off x="1858899" y="3601879"/>
-              <a:ext cx="2788211" cy="308039"/>
-            </a:xfrm>
-            <a:prstGeom prst="rect">
-              <a:avLst/>
-            </a:prstGeom>
-            <a:noFill/>
-            <a:ln>
-              <a:noFill/>
-            </a:ln>
-          </p:spPr>
-          <p:txBody>
-            <a:bodyPr wrap="none" lIns="0" tIns="0" rIns="0" bIns="0" anchor="t" anchorCtr="0">
-              <a:spAutoFit/>
-            </a:bodyPr>
-            <a:lstStyle/>
-            <a:p>
-              <a:pPr algn="l"/>
-              <a:r>
-                <a:rPr lang="en-US" sz="1580" dirty="0">
-                  <a:solidFill>
-                    <a:schemeClr val="dk1"/>
-                  </a:solidFill>
-                  <a:latin typeface="+mn-lt"/>
-                  <a:ea typeface="+mn-ea"/>
-                  <a:cs typeface="+mn-cs"/>
-                </a:rPr>
-                <a:t>Pairwise maximum-entropy</a:t>
-              </a:r>
-            </a:p>
-          </p:txBody>
-        </p:sp>
-        <p:sp>
-          <p:nvSpPr>
-            <p:cNvPr id="14" name="TextBox 14"/>
-            <p:cNvSpPr txBox="1"/>
-            <p:nvPr/>
-          </p:nvSpPr>
-          <p:spPr>
-            <a:xfrm>
-              <a:off x="1097280" y="4143375"/>
-              <a:ext cx="3962972" cy="293370"/>
-            </a:xfrm>
-            <a:prstGeom prst="rect">
-              <a:avLst/>
-            </a:prstGeom>
-            <a:noFill/>
-            <a:ln>
-              <a:noFill/>
-            </a:ln>
-          </p:spPr>
-          <p:txBody>
-            <a:bodyPr wrap="none" lIns="0" tIns="0" rIns="0" bIns="0" anchor="t" anchorCtr="0">
-              <a:spAutoFit/>
-            </a:bodyPr>
-            <a:lstStyle/>
-            <a:p>
-              <a:pPr algn="l"/>
-              <a:r>
-                <a:rPr lang="zh-CN" sz="1500" dirty="0">
-                  <a:solidFill>
-                    <a:schemeClr val="accent5"/>
-                  </a:solidFill>
-                  <a:latin typeface="+mn-lt"/>
-                  <a:ea typeface="+mn-ea"/>
-                  <a:cs typeface="+mn-cs"/>
-                </a:rPr>
-                <a:t>适合：是否、高低、出现/未出现等二值状态</a:t>
-              </a:r>
-            </a:p>
-          </p:txBody>
-        </p:sp>
-        <p:sp>
-          <p:nvSpPr>
-            <p:cNvPr id="15" name="TextBox 15"/>
-            <p:cNvSpPr txBox="1"/>
-            <p:nvPr/>
-          </p:nvSpPr>
-          <p:spPr>
-            <a:xfrm>
-              <a:off x="1097280" y="4467225"/>
-              <a:ext cx="3953192" cy="293370"/>
-            </a:xfrm>
-            <a:prstGeom prst="rect">
-              <a:avLst/>
-            </a:prstGeom>
-            <a:noFill/>
-            <a:ln>
-              <a:noFill/>
-            </a:ln>
-          </p:spPr>
-          <p:txBody>
-            <a:bodyPr wrap="none" lIns="0" tIns="0" rIns="0" bIns="0" anchor="t" anchorCtr="0">
-              <a:spAutoFit/>
-            </a:bodyPr>
-            <a:lstStyle/>
-            <a:p>
-              <a:pPr algn="l"/>
-              <a:r>
-                <a:rPr lang="zh-CN" sz="1500" dirty="0">
-                  <a:solidFill>
-                    <a:schemeClr val="accent5"/>
-                  </a:solidFill>
-                  <a:latin typeface="+mn-lt"/>
-                  <a:ea typeface="+mn-ea"/>
-                  <a:cs typeface="+mn-cs"/>
-                </a:rPr>
-                <a:t>计算：Exact enumeration 或 Monte Carlo</a:t>
-              </a:r>
-            </a:p>
-          </p:txBody>
-        </p:sp>
-        <p:sp>
-          <p:nvSpPr>
-            <p:cNvPr id="16" name="Rectangle 16"/>
-            <p:cNvSpPr/>
-            <p:nvPr/>
-          </p:nvSpPr>
-          <p:spPr>
-            <a:xfrm>
-              <a:off x="6534150" y="2952750"/>
-              <a:ext cx="4857750" cy="2019300"/>
-            </a:xfrm>
-            <a:prstGeom prst="roundRect">
-              <a:avLst>
-                <a:gd name="adj" fmla="val 8491"/>
+                <a:gd name="adj" fmla="val 12162"/>
               </a:avLst>
             </a:prstGeom>
             <a:solidFill>
@@ -16953,20 +16611,20 @@
         </p:sp>
         <p:sp>
           <p:nvSpPr>
-            <p:cNvPr id="17" name="Ellipse 17"/>
+            <p:cNvPr id="7" name="Ellipse 7"/>
             <p:cNvSpPr/>
             <p:nvPr/>
           </p:nvSpPr>
           <p:spPr>
             <a:xfrm>
-              <a:off x="6762750" y="3200400"/>
-              <a:ext cx="647700" cy="647700"/>
+              <a:off x="742950" y="2019300"/>
+              <a:ext cx="342900" cy="342900"/>
             </a:xfrm>
             <a:prstGeom prst="ellipse">
               <a:avLst/>
             </a:prstGeom>
             <a:solidFill>
-              <a:schemeClr val="accent3"/>
+              <a:schemeClr val="accent2"/>
             </a:solidFill>
             <a:ln>
               <a:noFill/>
@@ -16975,14 +16633,14 @@
         </p:sp>
         <p:sp>
           <p:nvSpPr>
-            <p:cNvPr id="18" name="TextBox 18"/>
-            <p:cNvSpPr txBox="1"/>
-            <p:nvPr/>
-          </p:nvSpPr>
-          <p:spPr>
-            <a:xfrm>
-              <a:off x="7007047" y="3406140"/>
-              <a:ext cx="159106" cy="352044"/>
+            <p:cNvPr id="8" name="TextBox 8"/>
+            <p:cNvSpPr txBox="1"/>
+            <p:nvPr/>
+          </p:nvSpPr>
+          <p:spPr>
+            <a:xfrm>
+              <a:off x="819455" y="2127885"/>
+              <a:ext cx="189890" cy="234696"/>
             </a:xfrm>
             <a:prstGeom prst="rect">
               <a:avLst/>
@@ -17000,87 +16658,87 @@
             <a:p>
               <a:pPr algn="ctr"/>
               <a:r>
-                <a:rPr lang="en-US" sz="1800" dirty="0">
+                <a:rPr lang="zh-CN" sz="1200" dirty="0">
                   <a:solidFill>
                     <a:srgbClr val="FFFFFF"/>
                   </a:solidFill>
-                  <a:latin typeface="+mj-lt"/>
-                  <a:ea typeface="+mj-ea"/>
-                  <a:cs typeface="+mj-cs"/>
-                </a:rPr>
-                <a:t>ℝ</a:t>
-              </a:r>
-            </a:p>
-          </p:txBody>
-        </p:sp>
-        <p:sp>
-          <p:nvSpPr>
-            <p:cNvPr id="19" name="TextBox 19"/>
-            <p:cNvSpPr txBox="1"/>
-            <p:nvPr/>
-          </p:nvSpPr>
-          <p:spPr>
-            <a:xfrm>
-              <a:off x="7589520" y="3186112"/>
-              <a:ext cx="3733528" cy="440055"/>
-            </a:xfrm>
-            <a:prstGeom prst="rect">
-              <a:avLst/>
-            </a:prstGeom>
-            <a:noFill/>
-            <a:ln>
-              <a:noFill/>
-            </a:ln>
-          </p:spPr>
-          <p:txBody>
-            <a:bodyPr wrap="none" lIns="0" tIns="0" rIns="0" bIns="0" anchor="t" anchorCtr="0">
-              <a:spAutoFit/>
-            </a:bodyPr>
-            <a:lstStyle/>
-            <a:p>
-              <a:pPr algn="l"/>
-              <a:r>
-                <a:rPr lang="en-US" sz="2250" dirty="0">
+                  <a:latin typeface="+mn-lt"/>
+                  <a:ea typeface="+mn-ea"/>
+                  <a:cs typeface="+mn-cs"/>
+                </a:rPr>
+                <a:t>01</a:t>
+              </a:r>
+            </a:p>
+          </p:txBody>
+        </p:sp>
+        <p:sp>
+          <p:nvSpPr>
+            <p:cNvPr id="9" name="TextBox 9"/>
+            <p:cNvSpPr txBox="1"/>
+            <p:nvPr/>
+          </p:nvSpPr>
+          <p:spPr>
+            <a:xfrm>
+              <a:off x="1192149" y="2077879"/>
+              <a:ext cx="866800" cy="308039"/>
+            </a:xfrm>
+            <a:prstGeom prst="rect">
+              <a:avLst/>
+            </a:prstGeom>
+            <a:noFill/>
+            <a:ln>
+              <a:noFill/>
+            </a:ln>
+          </p:spPr>
+          <p:txBody>
+            <a:bodyPr wrap="none" lIns="0" tIns="0" rIns="0" bIns="0" anchor="t" anchorCtr="0">
+              <a:spAutoFit/>
+            </a:bodyPr>
+            <a:lstStyle/>
+            <a:p>
+              <a:pPr algn="l"/>
+              <a:r>
+                <a:rPr lang="zh-CN" sz="1580" dirty="0">
                   <a:solidFill>
                     <a:schemeClr val="accent1"/>
                   </a:solidFill>
-                  <a:latin typeface="+mj-lt"/>
-                  <a:ea typeface="+mj-ea"/>
-                  <a:cs typeface="+mj-cs"/>
-                </a:rPr>
-                <a:t>ContinuousEnergyModel</a:t>
-              </a:r>
-            </a:p>
-          </p:txBody>
-        </p:sp>
-        <p:sp>
-          <p:nvSpPr>
-            <p:cNvPr id="20" name="TextBox 20"/>
-            <p:cNvSpPr txBox="1"/>
-            <p:nvPr/>
-          </p:nvSpPr>
-          <p:spPr>
-            <a:xfrm>
-              <a:off x="7592949" y="3601879"/>
-              <a:ext cx="2734596" cy="308039"/>
-            </a:xfrm>
-            <a:prstGeom prst="rect">
-              <a:avLst/>
-            </a:prstGeom>
-            <a:noFill/>
-            <a:ln>
-              <a:noFill/>
-            </a:ln>
-          </p:spPr>
-          <p:txBody>
-            <a:bodyPr wrap="none" lIns="0" tIns="0" rIns="0" bIns="0" anchor="t" anchorCtr="0">
-              <a:spAutoFit/>
-            </a:bodyPr>
-            <a:lstStyle/>
-            <a:p>
-              <a:pPr algn="l"/>
-              <a:r>
-                <a:rPr lang="en-US" sz="1580" dirty="0">
+                  <a:latin typeface="+mn-lt"/>
+                  <a:ea typeface="+mn-ea"/>
+                  <a:cs typeface="+mn-cs"/>
+                </a:rPr>
+                <a:t>概率表示</a:t>
+              </a:r>
+            </a:p>
+          </p:txBody>
+        </p:sp>
+        <p:sp>
+          <p:nvSpPr>
+            <p:cNvPr id="10" name="TextBox 10"/>
+            <p:cNvSpPr txBox="1"/>
+            <p:nvPr/>
+          </p:nvSpPr>
+          <p:spPr>
+            <a:xfrm>
+              <a:off x="831723" y="2510314"/>
+              <a:ext cx="1736090" cy="249364"/>
+            </a:xfrm>
+            <a:prstGeom prst="rect">
+              <a:avLst/>
+            </a:prstGeom>
+            <a:noFill/>
+            <a:ln>
+              <a:noFill/>
+            </a:ln>
+          </p:spPr>
+          <p:txBody>
+            <a:bodyPr wrap="none" lIns="0" tIns="0" rIns="0" bIns="0" anchor="t" anchorCtr="0">
+              <a:spAutoFit/>
+            </a:bodyPr>
+            <a:lstStyle/>
+            <a:p>
+              <a:pPr algn="l"/>
+              <a:r>
+                <a:rPr lang="zh-CN" sz="1280" dirty="0">
                   <a:solidFill>
                     <a:schemeClr val="dk1"/>
                   </a:solidFill>
@@ -17088,39 +16746,39 @@
                   <a:ea typeface="+mn-ea"/>
                   <a:cs typeface="+mn-cs"/>
                 </a:rPr>
-                <a:t>Gaussian quadratic energy</a:t>
-              </a:r>
-            </a:p>
-          </p:txBody>
-        </p:sp>
-        <p:sp>
-          <p:nvSpPr>
-            <p:cNvPr id="21" name="TextBox 21"/>
-            <p:cNvSpPr txBox="1"/>
-            <p:nvPr/>
-          </p:nvSpPr>
-          <p:spPr>
-            <a:xfrm>
-              <a:off x="6831330" y="4143375"/>
-              <a:ext cx="2842260" cy="293370"/>
-            </a:xfrm>
-            <a:prstGeom prst="rect">
-              <a:avLst/>
-            </a:prstGeom>
-            <a:noFill/>
-            <a:ln>
-              <a:noFill/>
-            </a:ln>
-          </p:spPr>
-          <p:txBody>
-            <a:bodyPr wrap="none" lIns="0" tIns="0" rIns="0" bIns="0" anchor="t" anchorCtr="0">
-              <a:spAutoFit/>
-            </a:bodyPr>
-            <a:lstStyle/>
-            <a:p>
-              <a:pPr algn="l"/>
-              <a:r>
-                <a:rPr lang="zh-CN" sz="1500" dirty="0">
+                <a:t>联合、边缘、条件概率</a:t>
+              </a:r>
+            </a:p>
+          </p:txBody>
+        </p:sp>
+        <p:sp>
+          <p:nvSpPr>
+            <p:cNvPr id="11" name="TextBox 11"/>
+            <p:cNvSpPr txBox="1"/>
+            <p:nvPr/>
+          </p:nvSpPr>
+          <p:spPr>
+            <a:xfrm>
+              <a:off x="832104" y="2842260"/>
+              <a:ext cx="1950720" cy="234696"/>
+            </a:xfrm>
+            <a:prstGeom prst="rect">
+              <a:avLst/>
+            </a:prstGeom>
+            <a:noFill/>
+            <a:ln>
+              <a:noFill/>
+            </a:ln>
+          </p:spPr>
+          <p:txBody>
+            <a:bodyPr wrap="none" lIns="0" tIns="0" rIns="0" bIns="0" anchor="t" anchorCtr="0">
+              <a:spAutoFit/>
+            </a:bodyPr>
+            <a:lstStyle/>
+            <a:p>
+              <a:pPr algn="l"/>
+              <a:r>
+                <a:rPr lang="zh-CN" sz="1200" dirty="0">
                   <a:solidFill>
                     <a:schemeClr val="accent5"/>
                   </a:solidFill>
@@ -17128,61 +16786,21 @@
                   <a:ea typeface="+mn-ea"/>
                   <a:cs typeface="+mn-cs"/>
                 </a:rPr>
-                <a:t>适合：分数、量表、连续测量值</a:t>
-              </a:r>
-            </a:p>
-          </p:txBody>
-        </p:sp>
-        <p:sp>
-          <p:nvSpPr>
-            <p:cNvPr id="22" name="TextBox 22"/>
-            <p:cNvSpPr txBox="1"/>
-            <p:nvPr/>
-          </p:nvSpPr>
-          <p:spPr>
-            <a:xfrm>
-              <a:off x="6831330" y="4467225"/>
-              <a:ext cx="3851910" cy="293370"/>
-            </a:xfrm>
-            <a:prstGeom prst="rect">
-              <a:avLst/>
-            </a:prstGeom>
-            <a:noFill/>
-            <a:ln>
-              <a:noFill/>
-            </a:ln>
-          </p:spPr>
-          <p:txBody>
-            <a:bodyPr wrap="none" lIns="0" tIns="0" rIns="0" bIns="0" anchor="t" anchorCtr="0">
-              <a:spAutoFit/>
-            </a:bodyPr>
-            <a:lstStyle/>
-            <a:p>
-              <a:pPr algn="l"/>
-              <a:r>
-                <a:rPr lang="zh-CN" sz="1500" dirty="0">
-                  <a:solidFill>
-                    <a:schemeClr val="accent5"/>
-                  </a:solidFill>
-                  <a:latin typeface="+mn-lt"/>
-                  <a:ea typeface="+mn-ea"/>
-                  <a:cs typeface="+mn-cs"/>
-                </a:rPr>
-                <a:t>计算：均值、协方差与精度矩阵的闭式估计</a:t>
-              </a:r>
-            </a:p>
-          </p:txBody>
-        </p:sp>
-        <p:sp>
-          <p:nvSpPr>
-            <p:cNvPr id="23" name="Line 23"/>
+                <a:t>输出：概率语言与解释边界</a:t>
+              </a:r>
+            </a:p>
+          </p:txBody>
+        </p:sp>
+        <p:sp>
+          <p:nvSpPr>
+            <p:cNvPr id="12" name="Line 12"/>
             <p:cNvSpPr/>
             <p:nvPr/>
           </p:nvSpPr>
           <p:spPr>
             <a:xfrm>
-              <a:off x="3238500" y="4972050"/>
-              <a:ext cx="1619250" cy="533400"/>
+              <a:off x="2990850" y="2590800"/>
+              <a:ext cx="304800" cy="9525"/>
             </a:xfrm>
             <a:custGeom>
               <a:avLst/>
@@ -17191,34 +16809,34 @@
               <a:cxnLst/>
               <a:rect l="l" t="t" r="r" b="b"/>
               <a:pathLst>
-                <a:path w="1619250" h="533400">
+                <a:path w="304800" h="9525">
                   <a:moveTo>
                     <a:pt x="0" y="0"/>
                   </a:moveTo>
                   <a:lnTo>
-                    <a:pt x="1619250" y="533400"/>
+                    <a:pt x="304800" y="0"/>
                   </a:lnTo>
                 </a:path>
               </a:pathLst>
             </a:custGeom>
             <a:noFill/>
-            <a:ln w="38100">
+            <a:ln w="28575">
               <a:solidFill>
-                <a:schemeClr val="accent6"/>
+                <a:schemeClr val="accent3"/>
               </a:solidFill>
             </a:ln>
           </p:spPr>
         </p:sp>
         <p:sp>
           <p:nvSpPr>
-            <p:cNvPr id="24" name="Line 24"/>
+            <p:cNvPr id="13" name="Freeform 13"/>
             <p:cNvSpPr/>
             <p:nvPr/>
           </p:nvSpPr>
           <p:spPr>
             <a:xfrm>
-              <a:off x="7334250" y="4972050"/>
-              <a:ext cx="1619250" cy="533400"/>
+              <a:off x="3200400" y="2524125"/>
+              <a:ext cx="95250" cy="133350"/>
             </a:xfrm>
             <a:custGeom>
               <a:avLst/>
@@ -17227,18 +16845,330 @@
               <a:cxnLst/>
               <a:rect l="l" t="t" r="r" b="b"/>
               <a:pathLst>
-                <a:path w="1619250" h="533400">
+                <a:path w="95250" h="133350">
                   <a:moveTo>
-                    <a:pt x="1619250" y="0"/>
+                    <a:pt x="95250" y="66675"/>
                   </a:moveTo>
                   <a:lnTo>
-                    <a:pt x="0" y="533400"/>
+                    <a:pt x="0" y="0"/>
+                  </a:lnTo>
+                  <a:lnTo>
+                    <a:pt x="0" y="133350"/>
+                  </a:lnTo>
+                  <a:close/>
+                </a:path>
+              </a:pathLst>
+            </a:custGeom>
+            <a:solidFill>
+              <a:schemeClr val="accent3"/>
+            </a:solidFill>
+            <a:ln>
+              <a:noFill/>
+            </a:ln>
+          </p:spPr>
+        </p:sp>
+        <p:sp>
+          <p:nvSpPr>
+            <p:cNvPr id="14" name="Rectangle 14"/>
+            <p:cNvSpPr/>
+            <p:nvPr/>
+          </p:nvSpPr>
+          <p:spPr>
+            <a:xfrm>
+              <a:off x="3371850" y="1885950"/>
+              <a:ext cx="2381250" cy="1409700"/>
+            </a:xfrm>
+            <a:prstGeom prst="roundRect">
+              <a:avLst>
+                <a:gd name="adj" fmla="val 12162"/>
+              </a:avLst>
+            </a:prstGeom>
+            <a:solidFill>
+              <a:schemeClr val="lt2"/>
+            </a:solidFill>
+            <a:ln>
+              <a:noFill/>
+            </a:ln>
+          </p:spPr>
+        </p:sp>
+        <p:sp>
+          <p:nvSpPr>
+            <p:cNvPr id="15" name="Ellipse 15"/>
+            <p:cNvSpPr/>
+            <p:nvPr/>
+          </p:nvSpPr>
+          <p:spPr>
+            <a:xfrm>
+              <a:off x="3505200" y="2019300"/>
+              <a:ext cx="342900" cy="342900"/>
+            </a:xfrm>
+            <a:prstGeom prst="ellipse">
+              <a:avLst/>
+            </a:prstGeom>
+            <a:solidFill>
+              <a:schemeClr val="accent2"/>
+            </a:solidFill>
+            <a:ln>
+              <a:noFill/>
+            </a:ln>
+          </p:spPr>
+        </p:sp>
+        <p:sp>
+          <p:nvSpPr>
+            <p:cNvPr id="16" name="TextBox 16"/>
+            <p:cNvSpPr txBox="1"/>
+            <p:nvPr/>
+          </p:nvSpPr>
+          <p:spPr>
+            <a:xfrm>
+              <a:off x="3581705" y="2127885"/>
+              <a:ext cx="189890" cy="234696"/>
+            </a:xfrm>
+            <a:prstGeom prst="rect">
+              <a:avLst/>
+            </a:prstGeom>
+            <a:noFill/>
+            <a:ln>
+              <a:noFill/>
+            </a:ln>
+          </p:spPr>
+          <p:txBody>
+            <a:bodyPr wrap="none" lIns="0" tIns="0" rIns="0" bIns="0" anchor="t" anchorCtr="0">
+              <a:spAutoFit/>
+            </a:bodyPr>
+            <a:lstStyle/>
+            <a:p>
+              <a:pPr algn="ctr"/>
+              <a:r>
+                <a:rPr lang="zh-CN" sz="1200" dirty="0">
+                  <a:solidFill>
+                    <a:srgbClr val="FFFFFF"/>
+                  </a:solidFill>
+                  <a:latin typeface="+mn-lt"/>
+                  <a:ea typeface="+mn-ea"/>
+                  <a:cs typeface="+mn-cs"/>
+                </a:rPr>
+                <a:t>02</a:t>
+              </a:r>
+            </a:p>
+          </p:txBody>
+        </p:sp>
+        <p:sp>
+          <p:nvSpPr>
+            <p:cNvPr id="17" name="TextBox 17"/>
+            <p:cNvSpPr txBox="1"/>
+            <p:nvPr/>
+          </p:nvSpPr>
+          <p:spPr>
+            <a:xfrm>
+              <a:off x="3954399" y="2077879"/>
+              <a:ext cx="866800" cy="308039"/>
+            </a:xfrm>
+            <a:prstGeom prst="rect">
+              <a:avLst/>
+            </a:prstGeom>
+            <a:noFill/>
+            <a:ln>
+              <a:noFill/>
+            </a:ln>
+          </p:spPr>
+          <p:txBody>
+            <a:bodyPr wrap="none" lIns="0" tIns="0" rIns="0" bIns="0" anchor="t" anchorCtr="0">
+              <a:spAutoFit/>
+            </a:bodyPr>
+            <a:lstStyle/>
+            <a:p>
+              <a:pPr algn="l"/>
+              <a:r>
+                <a:rPr lang="zh-CN" sz="1580" dirty="0">
+                  <a:solidFill>
+                    <a:schemeClr val="accent1"/>
+                  </a:solidFill>
+                  <a:latin typeface="+mn-lt"/>
+                  <a:ea typeface="+mn-ea"/>
+                  <a:cs typeface="+mn-cs"/>
+                </a:rPr>
+                <a:t>模型定义</a:t>
+              </a:r>
+            </a:p>
+          </p:txBody>
+        </p:sp>
+        <p:sp>
+          <p:nvSpPr>
+            <p:cNvPr id="18" name="TextBox 18"/>
+            <p:cNvSpPr txBox="1"/>
+            <p:nvPr/>
+          </p:nvSpPr>
+          <p:spPr>
+            <a:xfrm>
+              <a:off x="3593973" y="2510314"/>
+              <a:ext cx="2123796" cy="249364"/>
+            </a:xfrm>
+            <a:prstGeom prst="rect">
+              <a:avLst/>
+            </a:prstGeom>
+            <a:noFill/>
+            <a:ln>
+              <a:noFill/>
+            </a:ln>
+          </p:spPr>
+          <p:txBody>
+            <a:bodyPr wrap="none" lIns="0" tIns="0" rIns="0" bIns="0" anchor="t" anchorCtr="0">
+              <a:spAutoFit/>
+            </a:bodyPr>
+            <a:lstStyle/>
+            <a:p>
+              <a:pPr algn="l"/>
+              <a:r>
+                <a:rPr lang="zh-CN" sz="1280" dirty="0">
+                  <a:solidFill>
+                    <a:schemeClr val="dk1"/>
+                  </a:solidFill>
+                  <a:latin typeface="+mn-lt"/>
+                  <a:ea typeface="+mn-ea"/>
+                  <a:cs typeface="+mn-cs"/>
+                </a:rPr>
+                <a:t>状态空间、能量、moments</a:t>
+              </a:r>
+            </a:p>
+          </p:txBody>
+        </p:sp>
+        <p:sp>
+          <p:nvSpPr>
+            <p:cNvPr id="19" name="TextBox 19"/>
+            <p:cNvSpPr txBox="1"/>
+            <p:nvPr/>
+          </p:nvSpPr>
+          <p:spPr>
+            <a:xfrm>
+              <a:off x="3594354" y="2842260"/>
+              <a:ext cx="2186940" cy="234696"/>
+            </a:xfrm>
+            <a:prstGeom prst="rect">
+              <a:avLst/>
+            </a:prstGeom>
+            <a:noFill/>
+            <a:ln>
+              <a:noFill/>
+            </a:ln>
+          </p:spPr>
+          <p:txBody>
+            <a:bodyPr wrap="none" lIns="0" tIns="0" rIns="0" bIns="0" anchor="t" anchorCtr="0">
+              <a:spAutoFit/>
+            </a:bodyPr>
+            <a:lstStyle/>
+            <a:p>
+              <a:pPr algn="l"/>
+              <a:r>
+                <a:rPr lang="zh-CN" sz="1200" dirty="0">
+                  <a:solidFill>
+                    <a:schemeClr val="accent5"/>
+                  </a:solidFill>
+                  <a:latin typeface="+mn-lt"/>
+                  <a:ea typeface="+mn-ea"/>
+                  <a:cs typeface="+mn-cs"/>
+                </a:rPr>
+                <a:t>输出：E(s)、p(s)、训练约束</a:t>
+              </a:r>
+            </a:p>
+          </p:txBody>
+        </p:sp>
+        <p:sp>
+          <p:nvSpPr>
+            <p:cNvPr id="20" name="Line 20"/>
+            <p:cNvSpPr/>
+            <p:nvPr/>
+          </p:nvSpPr>
+          <p:spPr>
+            <a:xfrm>
+              <a:off x="5753100" y="2590800"/>
+              <a:ext cx="304800" cy="9525"/>
+            </a:xfrm>
+            <a:custGeom>
+              <a:avLst/>
+              <a:gdLst/>
+              <a:ahLst/>
+              <a:cxnLst/>
+              <a:rect l="l" t="t" r="r" b="b"/>
+              <a:pathLst>
+                <a:path w="304800" h="9525">
+                  <a:moveTo>
+                    <a:pt x="0" y="0"/>
+                  </a:moveTo>
+                  <a:lnTo>
+                    <a:pt x="304800" y="0"/>
                   </a:lnTo>
                 </a:path>
               </a:pathLst>
             </a:custGeom>
             <a:noFill/>
-            <a:ln w="38100">
+            <a:ln w="28575">
+              <a:solidFill>
+                <a:schemeClr val="accent3"/>
+              </a:solidFill>
+            </a:ln>
+          </p:spPr>
+        </p:sp>
+        <p:sp>
+          <p:nvSpPr>
+            <p:cNvPr id="21" name="Freeform 21"/>
+            <p:cNvSpPr/>
+            <p:nvPr/>
+          </p:nvSpPr>
+          <p:spPr>
+            <a:xfrm>
+              <a:off x="5962650" y="2524125"/>
+              <a:ext cx="95250" cy="133350"/>
+            </a:xfrm>
+            <a:custGeom>
+              <a:avLst/>
+              <a:gdLst/>
+              <a:ahLst/>
+              <a:cxnLst/>
+              <a:rect l="l" t="t" r="r" b="b"/>
+              <a:pathLst>
+                <a:path w="95250" h="133350">
+                  <a:moveTo>
+                    <a:pt x="95250" y="66675"/>
+                  </a:moveTo>
+                  <a:lnTo>
+                    <a:pt x="0" y="0"/>
+                  </a:lnTo>
+                  <a:lnTo>
+                    <a:pt x="0" y="133350"/>
+                  </a:lnTo>
+                  <a:close/>
+                </a:path>
+              </a:pathLst>
+            </a:custGeom>
+            <a:solidFill>
+              <a:schemeClr val="accent3"/>
+            </a:solidFill>
+            <a:ln>
+              <a:noFill/>
+            </a:ln>
+          </p:spPr>
+        </p:sp>
+        <p:sp>
+          <p:nvSpPr>
+            <p:cNvPr id="22" name="Rectangle 22"/>
+            <p:cNvSpPr/>
+            <p:nvPr/>
+          </p:nvSpPr>
+          <p:spPr>
+            <a:xfrm>
+              <a:off x="6134100" y="1885950"/>
+              <a:ext cx="2381250" cy="1409700"/>
+            </a:xfrm>
+            <a:prstGeom prst="roundRect">
+              <a:avLst>
+                <a:gd name="adj" fmla="val 12162"/>
+              </a:avLst>
+            </a:prstGeom>
+            <a:solidFill>
+              <a:srgbClr val="FFFFFF"/>
+            </a:solidFill>
+            <a:ln w="19050">
               <a:solidFill>
                 <a:schemeClr val="accent6"/>
               </a:solidFill>
@@ -17247,18 +17177,276 @@
         </p:sp>
         <p:sp>
           <p:nvSpPr>
-            <p:cNvPr id="25" name="Rectangle 25"/>
+            <p:cNvPr id="23" name="Ellipse 23"/>
             <p:cNvSpPr/>
             <p:nvPr/>
           </p:nvSpPr>
           <p:spPr>
             <a:xfrm>
-              <a:off x="3200400" y="5391150"/>
-              <a:ext cx="5791200" cy="590550"/>
+              <a:off x="6267450" y="2019300"/>
+              <a:ext cx="342900" cy="342900"/>
+            </a:xfrm>
+            <a:prstGeom prst="ellipse">
+              <a:avLst/>
+            </a:prstGeom>
+            <a:solidFill>
+              <a:schemeClr val="accent2"/>
+            </a:solidFill>
+            <a:ln>
+              <a:noFill/>
+            </a:ln>
+          </p:spPr>
+        </p:sp>
+        <p:sp>
+          <p:nvSpPr>
+            <p:cNvPr id="24" name="TextBox 24"/>
+            <p:cNvSpPr txBox="1"/>
+            <p:nvPr/>
+          </p:nvSpPr>
+          <p:spPr>
+            <a:xfrm>
+              <a:off x="6343955" y="2127885"/>
+              <a:ext cx="189890" cy="234696"/>
+            </a:xfrm>
+            <a:prstGeom prst="rect">
+              <a:avLst/>
+            </a:prstGeom>
+            <a:noFill/>
+            <a:ln>
+              <a:noFill/>
+            </a:ln>
+          </p:spPr>
+          <p:txBody>
+            <a:bodyPr wrap="none" lIns="0" tIns="0" rIns="0" bIns="0" anchor="t" anchorCtr="0">
+              <a:spAutoFit/>
+            </a:bodyPr>
+            <a:lstStyle/>
+            <a:p>
+              <a:pPr algn="ctr"/>
+              <a:r>
+                <a:rPr lang="zh-CN" sz="1200" dirty="0">
+                  <a:solidFill>
+                    <a:srgbClr val="FFFFFF"/>
+                  </a:solidFill>
+                  <a:latin typeface="+mn-lt"/>
+                  <a:ea typeface="+mn-ea"/>
+                  <a:cs typeface="+mn-cs"/>
+                </a:rPr>
+                <a:t>03</a:t>
+              </a:r>
+            </a:p>
+          </p:txBody>
+        </p:sp>
+        <p:sp>
+          <p:nvSpPr>
+            <p:cNvPr id="25" name="TextBox 25"/>
+            <p:cNvSpPr txBox="1"/>
+            <p:nvPr/>
+          </p:nvSpPr>
+          <p:spPr>
+            <a:xfrm>
+              <a:off x="6716649" y="2077879"/>
+              <a:ext cx="1079500" cy="308039"/>
+            </a:xfrm>
+            <a:prstGeom prst="rect">
+              <a:avLst/>
+            </a:prstGeom>
+            <a:noFill/>
+            <a:ln>
+              <a:noFill/>
+            </a:ln>
+          </p:spPr>
+          <p:txBody>
+            <a:bodyPr wrap="none" lIns="0" tIns="0" rIns="0" bIns="0" anchor="t" anchorCtr="0">
+              <a:spAutoFit/>
+            </a:bodyPr>
+            <a:lstStyle/>
+            <a:p>
+              <a:pPr algn="l"/>
+              <a:r>
+                <a:rPr lang="zh-CN" sz="1580" dirty="0">
+                  <a:solidFill>
+                    <a:schemeClr val="accent1"/>
+                  </a:solidFill>
+                  <a:latin typeface="+mn-lt"/>
+                  <a:ea typeface="+mn-ea"/>
+                  <a:cs typeface="+mn-cs"/>
+                </a:rPr>
+                <a:t>计算与训练</a:t>
+              </a:r>
+            </a:p>
+          </p:txBody>
+        </p:sp>
+        <p:sp>
+          <p:nvSpPr>
+            <p:cNvPr id="26" name="TextBox 26"/>
+            <p:cNvSpPr txBox="1"/>
+            <p:nvPr/>
+          </p:nvSpPr>
+          <p:spPr>
+            <a:xfrm>
+              <a:off x="6356223" y="2510314"/>
+              <a:ext cx="2405425" cy="249364"/>
+            </a:xfrm>
+            <a:prstGeom prst="rect">
+              <a:avLst/>
+            </a:prstGeom>
+            <a:noFill/>
+            <a:ln>
+              <a:noFill/>
+            </a:ln>
+          </p:spPr>
+          <p:txBody>
+            <a:bodyPr wrap="none" lIns="0" tIns="0" rIns="0" bIns="0" anchor="t" anchorCtr="0">
+              <a:spAutoFit/>
+            </a:bodyPr>
+            <a:lstStyle/>
+            <a:p>
+              <a:pPr algn="l"/>
+              <a:r>
+                <a:rPr lang="zh-CN" sz="1280" dirty="0">
+                  <a:solidFill>
+                    <a:schemeClr val="dk1"/>
+                  </a:solidFill>
+                  <a:latin typeface="+mn-lt"/>
+                  <a:ea typeface="+mn-ea"/>
+                  <a:cs typeface="+mn-cs"/>
+                </a:rPr>
+                <a:t>Exact / MC；MM / KL / Adam</a:t>
+              </a:r>
+            </a:p>
+          </p:txBody>
+        </p:sp>
+        <p:sp>
+          <p:nvSpPr>
+            <p:cNvPr id="27" name="TextBox 27"/>
+            <p:cNvSpPr txBox="1"/>
+            <p:nvPr/>
+          </p:nvSpPr>
+          <p:spPr>
+            <a:xfrm>
+              <a:off x="6356604" y="2842260"/>
+              <a:ext cx="2141220" cy="234696"/>
+            </a:xfrm>
+            <a:prstGeom prst="rect">
+              <a:avLst/>
+            </a:prstGeom>
+            <a:noFill/>
+            <a:ln>
+              <a:noFill/>
+            </a:ln>
+          </p:spPr>
+          <p:txBody>
+            <a:bodyPr wrap="none" lIns="0" tIns="0" rIns="0" bIns="0" anchor="t" anchorCtr="0">
+              <a:spAutoFit/>
+            </a:bodyPr>
+            <a:lstStyle/>
+            <a:p>
+              <a:pPr algn="l"/>
+              <a:r>
+                <a:rPr lang="zh-CN" sz="1200" dirty="0">
+                  <a:solidFill>
+                    <a:schemeClr val="accent5"/>
+                  </a:solidFill>
+                  <a:latin typeface="+mn-lt"/>
+                  <a:ea typeface="+mn-ea"/>
+                  <a:cs typeface="+mn-cs"/>
+                </a:rPr>
+                <a:t>输出：拟合参数 h、J 或 μ、Σ</a:t>
+              </a:r>
+            </a:p>
+          </p:txBody>
+        </p:sp>
+        <p:sp>
+          <p:nvSpPr>
+            <p:cNvPr id="28" name="Line 28"/>
+            <p:cNvSpPr/>
+            <p:nvPr/>
+          </p:nvSpPr>
+          <p:spPr>
+            <a:xfrm>
+              <a:off x="8515350" y="2590800"/>
+              <a:ext cx="304800" cy="9525"/>
+            </a:xfrm>
+            <a:custGeom>
+              <a:avLst/>
+              <a:gdLst/>
+              <a:ahLst/>
+              <a:cxnLst/>
+              <a:rect l="l" t="t" r="r" b="b"/>
+              <a:pathLst>
+                <a:path w="304800" h="9525">
+                  <a:moveTo>
+                    <a:pt x="0" y="0"/>
+                  </a:moveTo>
+                  <a:lnTo>
+                    <a:pt x="304800" y="0"/>
+                  </a:lnTo>
+                </a:path>
+              </a:pathLst>
+            </a:custGeom>
+            <a:noFill/>
+            <a:ln w="28575">
+              <a:solidFill>
+                <a:schemeClr val="accent3"/>
+              </a:solidFill>
+            </a:ln>
+          </p:spPr>
+        </p:sp>
+        <p:sp>
+          <p:nvSpPr>
+            <p:cNvPr id="29" name="Freeform 29"/>
+            <p:cNvSpPr/>
+            <p:nvPr/>
+          </p:nvSpPr>
+          <p:spPr>
+            <a:xfrm>
+              <a:off x="8724900" y="2524125"/>
+              <a:ext cx="95250" cy="133350"/>
+            </a:xfrm>
+            <a:custGeom>
+              <a:avLst/>
+              <a:gdLst/>
+              <a:ahLst/>
+              <a:cxnLst/>
+              <a:rect l="l" t="t" r="r" b="b"/>
+              <a:pathLst>
+                <a:path w="95250" h="133350">
+                  <a:moveTo>
+                    <a:pt x="95250" y="66675"/>
+                  </a:moveTo>
+                  <a:lnTo>
+                    <a:pt x="0" y="0"/>
+                  </a:lnTo>
+                  <a:lnTo>
+                    <a:pt x="0" y="133350"/>
+                  </a:lnTo>
+                  <a:close/>
+                </a:path>
+              </a:pathLst>
+            </a:custGeom>
+            <a:solidFill>
+              <a:schemeClr val="accent3"/>
+            </a:solidFill>
+            <a:ln>
+              <a:noFill/>
+            </a:ln>
+          </p:spPr>
+        </p:sp>
+        <p:sp>
+          <p:nvSpPr>
+            <p:cNvPr id="30" name="Rectangle 30"/>
+            <p:cNvSpPr/>
+            <p:nvPr/>
+          </p:nvSpPr>
+          <p:spPr>
+            <a:xfrm>
+              <a:off x="8896350" y="1885950"/>
+              <a:ext cx="2686050" cy="1409700"/>
             </a:xfrm>
             <a:prstGeom prst="roundRect">
               <a:avLst>
-                <a:gd name="adj" fmla="val 19355"/>
+                <a:gd name="adj" fmla="val 12162"/>
               </a:avLst>
             </a:prstGeom>
             <a:solidFill>
@@ -17271,14 +17459,36 @@
         </p:sp>
         <p:sp>
           <p:nvSpPr>
-            <p:cNvPr id="26" name="TextBox 26"/>
-            <p:cNvSpPr txBox="1"/>
-            <p:nvPr/>
-          </p:nvSpPr>
-          <p:spPr>
-            <a:xfrm>
-              <a:off x="3311080" y="5584508"/>
-              <a:ext cx="5569839" cy="322707"/>
+            <p:cNvPr id="31" name="Ellipse 31"/>
+            <p:cNvSpPr/>
+            <p:nvPr/>
+          </p:nvSpPr>
+          <p:spPr>
+            <a:xfrm>
+              <a:off x="9029700" y="2019300"/>
+              <a:ext cx="342900" cy="342900"/>
+            </a:xfrm>
+            <a:prstGeom prst="ellipse">
+              <a:avLst/>
+            </a:prstGeom>
+            <a:solidFill>
+              <a:schemeClr val="accent2"/>
+            </a:solidFill>
+            <a:ln>
+              <a:noFill/>
+            </a:ln>
+          </p:spPr>
+        </p:sp>
+        <p:sp>
+          <p:nvSpPr>
+            <p:cNvPr id="32" name="TextBox 32"/>
+            <p:cNvSpPr txBox="1"/>
+            <p:nvPr/>
+          </p:nvSpPr>
+          <p:spPr>
+            <a:xfrm>
+              <a:off x="9106205" y="2127885"/>
+              <a:ext cx="189890" cy="234696"/>
             </a:xfrm>
             <a:prstGeom prst="rect">
               <a:avLst/>
@@ -17296,7 +17506,7 @@
             <a:p>
               <a:pPr algn="ctr"/>
               <a:r>
-                <a:rPr lang="zh-CN" sz="1650" dirty="0">
+                <a:rPr lang="zh-CN" sz="1200" dirty="0">
                   <a:solidFill>
                     <a:srgbClr val="FFFFFF"/>
                   </a:solidFill>
@@ -17304,52 +17514,1213 @@
                   <a:ea typeface="+mn-ea"/>
                   <a:cs typeface="+mn-cs"/>
                 </a:rPr>
-                <a:t>共同工作流：fit → diagnose → interpret → save / load</a:t>
+                <a:t>04</a:t>
+              </a:r>
+            </a:p>
+          </p:txBody>
+        </p:sp>
+        <p:sp>
+          <p:nvSpPr>
+            <p:cNvPr id="33" name="TextBox 33"/>
+            <p:cNvSpPr txBox="1"/>
+            <p:nvPr/>
+          </p:nvSpPr>
+          <p:spPr>
+            <a:xfrm>
+              <a:off x="9478899" y="2077879"/>
+              <a:ext cx="1079500" cy="308039"/>
+            </a:xfrm>
+            <a:prstGeom prst="rect">
+              <a:avLst/>
+            </a:prstGeom>
+            <a:noFill/>
+            <a:ln>
+              <a:noFill/>
+            </a:ln>
+          </p:spPr>
+          <p:txBody>
+            <a:bodyPr wrap="none" lIns="0" tIns="0" rIns="0" bIns="0" anchor="t" anchorCtr="0">
+              <a:spAutoFit/>
+            </a:bodyPr>
+            <a:lstStyle/>
+            <a:p>
+              <a:pPr algn="l"/>
+              <a:r>
+                <a:rPr lang="zh-CN" sz="1580" dirty="0">
+                  <a:solidFill>
+                    <a:srgbClr val="FFFFFF"/>
+                  </a:solidFill>
+                  <a:latin typeface="+mn-lt"/>
+                  <a:ea typeface="+mn-ea"/>
+                  <a:cs typeface="+mn-cs"/>
+                </a:rPr>
+                <a:t>解释与诊断</a:t>
+              </a:r>
+            </a:p>
+          </p:txBody>
+        </p:sp>
+        <p:sp>
+          <p:nvSpPr>
+            <p:cNvPr id="34" name="TextBox 34"/>
+            <p:cNvSpPr txBox="1"/>
+            <p:nvPr/>
+          </p:nvSpPr>
+          <p:spPr>
+            <a:xfrm>
+              <a:off x="9118473" y="2510314"/>
+              <a:ext cx="1908404" cy="249364"/>
+            </a:xfrm>
+            <a:prstGeom prst="rect">
+              <a:avLst/>
+            </a:prstGeom>
+            <a:noFill/>
+            <a:ln>
+              <a:noFill/>
+            </a:ln>
+          </p:spPr>
+          <p:txBody>
+            <a:bodyPr wrap="none" lIns="0" tIns="0" rIns="0" bIns="0" anchor="t" anchorCtr="0">
+              <a:spAutoFit/>
+            </a:bodyPr>
+            <a:lstStyle/>
+            <a:p>
+              <a:pPr algn="l"/>
+              <a:r>
+                <a:rPr lang="zh-CN" sz="1280" dirty="0">
+                  <a:solidFill>
+                    <a:srgbClr val="FFFFFF"/>
+                  </a:solidFill>
+                  <a:latin typeface="+mn-lt"/>
+                  <a:ea typeface="+mn-ea"/>
+                  <a:cs typeface="+mn-cs"/>
+                </a:rPr>
+                <a:t>参数、交互与敏感性响应</a:t>
+              </a:r>
+            </a:p>
+          </p:txBody>
+        </p:sp>
+        <p:sp>
+          <p:nvSpPr>
+            <p:cNvPr id="35" name="TextBox 35"/>
+            <p:cNvSpPr txBox="1"/>
+            <p:nvPr/>
+          </p:nvSpPr>
+          <p:spPr>
+            <a:xfrm>
+              <a:off x="9118854" y="2842260"/>
+              <a:ext cx="1789176" cy="234696"/>
+            </a:xfrm>
+            <a:prstGeom prst="rect">
+              <a:avLst/>
+            </a:prstGeom>
+            <a:noFill/>
+            <a:ln>
+              <a:noFill/>
+            </a:ln>
+          </p:spPr>
+          <p:txBody>
+            <a:bodyPr wrap="none" lIns="0" tIns="0" rIns="0" bIns="0" anchor="t" anchorCtr="0">
+              <a:spAutoFit/>
+            </a:bodyPr>
+            <a:lstStyle/>
+            <a:p>
+              <a:pPr algn="l"/>
+              <a:r>
+                <a:rPr lang="zh-CN" sz="1200" dirty="0">
+                  <a:solidFill>
+                    <a:schemeClr val="accent6"/>
+                  </a:solidFill>
+                  <a:latin typeface="+mn-lt"/>
+                  <a:ea typeface="+mn-ea"/>
+                  <a:cs typeface="+mn-cs"/>
+                </a:rPr>
+                <a:t>输出：有边界的模型结论</a:t>
               </a:r>
             </a:p>
           </p:txBody>
         </p:sp>
       </p:grpSp>
-      <p:sp>
-        <p:nvSpPr>
-          <p:cNvPr id="28" name="TextBox 28"/>
-          <p:cNvSpPr txBox="1"/>
+      <p:grpSp>
+        <p:nvGrpSpPr>
+          <p:cNvPr id="61" name="p02-row-two"/>
+          <p:cNvGrpSpPr/>
           <p:nvPr/>
-        </p:nvSpPr>
-        <p:spPr>
+        </p:nvGrpSpPr>
+        <p:grpSpPr>
           <a:xfrm>
-            <a:off x="604266" y="6516052"/>
-            <a:ext cx="2484311" cy="205359"/>
+            <a:off x="1657350" y="3295650"/>
+            <a:ext cx="8877300" cy="1866900"/>
+            <a:chOff x="1657350" y="3295650"/>
+            <a:chExt cx="8877300" cy="1866900"/>
           </a:xfrm>
-          <a:prstGeom prst="rect">
-            <a:avLst/>
-          </a:prstGeom>
-          <a:noFill/>
-          <a:ln>
-            <a:noFill/>
-          </a:ln>
-        </p:spPr>
-        <p:txBody>
-          <a:bodyPr wrap="none" lIns="0" tIns="0" rIns="0" bIns="0" anchor="t" anchorCtr="0">
-            <a:spAutoFit/>
-          </a:bodyPr>
-          <a:lstStyle/>
-          <a:p>
-            <a:pPr algn="l"/>
-            <a:r>
-              <a:rPr lang="zh-CN" sz="1050" dirty="0">
-                <a:solidFill>
-                  <a:schemeClr val="accent5"/>
-                </a:solidFill>
-                <a:latin typeface="+mn-lt"/>
-                <a:ea typeface="+mn-ea"/>
-                <a:cs typeface="+mn-cs"/>
-              </a:rPr>
-              <a:t>02 / 30 · 模型选择依据：变量状态空间</a:t>
-            </a:r>
-          </a:p>
-        </p:txBody>
-      </p:sp>
+        </p:grpSpPr>
+        <p:sp>
+          <p:nvSpPr>
+            <p:cNvPr id="37" name="Freeform 37"/>
+            <p:cNvSpPr/>
+            <p:nvPr/>
+          </p:nvSpPr>
+          <p:spPr>
+            <a:xfrm>
+              <a:off x="2971800" y="3295650"/>
+              <a:ext cx="7267575" cy="438150"/>
+            </a:xfrm>
+            <a:custGeom>
+              <a:avLst/>
+              <a:gdLst/>
+              <a:ahLst/>
+              <a:cxnLst/>
+              <a:rect l="l" t="t" r="r" b="b"/>
+              <a:pathLst>
+                <a:path w="7267575" h="438150">
+                  <a:moveTo>
+                    <a:pt x="7267575" y="0"/>
+                  </a:moveTo>
+                  <a:lnTo>
+                    <a:pt x="7267575" y="266700"/>
+                  </a:lnTo>
+                  <a:lnTo>
+                    <a:pt x="0" y="266700"/>
+                  </a:lnTo>
+                  <a:lnTo>
+                    <a:pt x="0" y="438150"/>
+                  </a:lnTo>
+                </a:path>
+              </a:pathLst>
+            </a:custGeom>
+            <a:noFill/>
+            <a:ln w="28575">
+              <a:solidFill>
+                <a:schemeClr val="accent3"/>
+              </a:solidFill>
+            </a:ln>
+          </p:spPr>
+        </p:sp>
+        <p:sp>
+          <p:nvSpPr>
+            <p:cNvPr id="38" name="Freeform 38"/>
+            <p:cNvSpPr/>
+            <p:nvPr/>
+          </p:nvSpPr>
+          <p:spPr>
+            <a:xfrm>
+              <a:off x="2905125" y="3714750"/>
+              <a:ext cx="133350" cy="95250"/>
+            </a:xfrm>
+            <a:custGeom>
+              <a:avLst/>
+              <a:gdLst/>
+              <a:ahLst/>
+              <a:cxnLst/>
+              <a:rect l="l" t="t" r="r" b="b"/>
+              <a:pathLst>
+                <a:path w="133350" h="95250">
+                  <a:moveTo>
+                    <a:pt x="66675" y="95250"/>
+                  </a:moveTo>
+                  <a:lnTo>
+                    <a:pt x="0" y="0"/>
+                  </a:lnTo>
+                  <a:lnTo>
+                    <a:pt x="133350" y="0"/>
+                  </a:lnTo>
+                  <a:close/>
+                </a:path>
+              </a:pathLst>
+            </a:custGeom>
+            <a:solidFill>
+              <a:schemeClr val="accent3"/>
+            </a:solidFill>
+            <a:ln>
+              <a:noFill/>
+            </a:ln>
+          </p:spPr>
+        </p:sp>
+        <p:sp>
+          <p:nvSpPr>
+            <p:cNvPr id="39" name="Rectangle 39"/>
+            <p:cNvSpPr/>
+            <p:nvPr/>
+          </p:nvSpPr>
+          <p:spPr>
+            <a:xfrm>
+              <a:off x="1657350" y="3810000"/>
+              <a:ext cx="2628900" cy="1352550"/>
+            </a:xfrm>
+            <a:prstGeom prst="roundRect">
+              <a:avLst>
+                <a:gd name="adj" fmla="val 12676"/>
+              </a:avLst>
+            </a:prstGeom>
+            <a:solidFill>
+              <a:srgbClr val="FFFFFF"/>
+            </a:solidFill>
+            <a:ln w="19050">
+              <a:solidFill>
+                <a:schemeClr val="accent6"/>
+              </a:solidFill>
+            </a:ln>
+          </p:spPr>
+        </p:sp>
+        <p:sp>
+          <p:nvSpPr>
+            <p:cNvPr id="40" name="Ellipse 40"/>
+            <p:cNvSpPr/>
+            <p:nvPr/>
+          </p:nvSpPr>
+          <p:spPr>
+            <a:xfrm>
+              <a:off x="1790700" y="3943350"/>
+              <a:ext cx="342900" cy="342900"/>
+            </a:xfrm>
+            <a:prstGeom prst="ellipse">
+              <a:avLst/>
+            </a:prstGeom>
+            <a:solidFill>
+              <a:schemeClr val="accent2"/>
+            </a:solidFill>
+            <a:ln>
+              <a:noFill/>
+            </a:ln>
+          </p:spPr>
+        </p:sp>
+        <p:sp>
+          <p:nvSpPr>
+            <p:cNvPr id="41" name="TextBox 41"/>
+            <p:cNvSpPr txBox="1"/>
+            <p:nvPr/>
+          </p:nvSpPr>
+          <p:spPr>
+            <a:xfrm>
+              <a:off x="1867205" y="4051935"/>
+              <a:ext cx="189890" cy="234696"/>
+            </a:xfrm>
+            <a:prstGeom prst="rect">
+              <a:avLst/>
+            </a:prstGeom>
+            <a:noFill/>
+            <a:ln>
+              <a:noFill/>
+            </a:ln>
+          </p:spPr>
+          <p:txBody>
+            <a:bodyPr wrap="none" lIns="0" tIns="0" rIns="0" bIns="0" anchor="t" anchorCtr="0">
+              <a:spAutoFit/>
+            </a:bodyPr>
+            <a:lstStyle/>
+            <a:p>
+              <a:pPr algn="ctr"/>
+              <a:r>
+                <a:rPr lang="zh-CN" sz="1200" dirty="0">
+                  <a:solidFill>
+                    <a:srgbClr val="FFFFFF"/>
+                  </a:solidFill>
+                  <a:latin typeface="+mn-lt"/>
+                  <a:ea typeface="+mn-ea"/>
+                  <a:cs typeface="+mn-cs"/>
+                </a:rPr>
+                <a:t>05</a:t>
+              </a:r>
+            </a:p>
+          </p:txBody>
+        </p:sp>
+        <p:sp>
+          <p:nvSpPr>
+            <p:cNvPr id="42" name="TextBox 42"/>
+            <p:cNvSpPr txBox="1"/>
+            <p:nvPr/>
+          </p:nvSpPr>
+          <p:spPr>
+            <a:xfrm>
+              <a:off x="2239899" y="4001929"/>
+              <a:ext cx="1292200" cy="308039"/>
+            </a:xfrm>
+            <a:prstGeom prst="rect">
+              <a:avLst/>
+            </a:prstGeom>
+            <a:noFill/>
+            <a:ln>
+              <a:noFill/>
+            </a:ln>
+          </p:spPr>
+          <p:txBody>
+            <a:bodyPr wrap="none" lIns="0" tIns="0" rIns="0" bIns="0" anchor="t" anchorCtr="0">
+              <a:spAutoFit/>
+            </a:bodyPr>
+            <a:lstStyle/>
+            <a:p>
+              <a:pPr algn="l"/>
+              <a:r>
+                <a:rPr lang="zh-CN" sz="1580" dirty="0">
+                  <a:solidFill>
+                    <a:schemeClr val="accent1"/>
+                  </a:solidFill>
+                  <a:latin typeface="+mn-lt"/>
+                  <a:ea typeface="+mn-ea"/>
+                  <a:cs typeface="+mn-cs"/>
+                </a:rPr>
+                <a:t>连续模型扩展</a:t>
+              </a:r>
+            </a:p>
+          </p:txBody>
+        </p:sp>
+        <p:sp>
+          <p:nvSpPr>
+            <p:cNvPr id="43" name="TextBox 43"/>
+            <p:cNvSpPr txBox="1"/>
+            <p:nvPr/>
+          </p:nvSpPr>
+          <p:spPr>
+            <a:xfrm>
+              <a:off x="1879473" y="4434364"/>
+              <a:ext cx="2419411" cy="249364"/>
+            </a:xfrm>
+            <a:prstGeom prst="rect">
+              <a:avLst/>
+            </a:prstGeom>
+            <a:noFill/>
+            <a:ln>
+              <a:noFill/>
+            </a:ln>
+          </p:spPr>
+          <p:txBody>
+            <a:bodyPr wrap="none" lIns="0" tIns="0" rIns="0" bIns="0" anchor="t" anchorCtr="0">
+              <a:spAutoFit/>
+            </a:bodyPr>
+            <a:lstStyle/>
+            <a:p>
+              <a:pPr algn="l"/>
+              <a:r>
+                <a:rPr lang="en-US" sz="1280" dirty="0">
+                  <a:solidFill>
+                    <a:schemeClr val="dk1"/>
+                  </a:solidFill>
+                  <a:latin typeface="+mn-lt"/>
+                  <a:ea typeface="+mn-ea"/>
+                  <a:cs typeface="+mn-cs"/>
+                </a:rPr>
+                <a:t>Binary → Gaussian joint model</a:t>
+              </a:r>
+            </a:p>
+          </p:txBody>
+        </p:sp>
+        <p:sp>
+          <p:nvSpPr>
+            <p:cNvPr id="44" name="TextBox 44"/>
+            <p:cNvSpPr txBox="1"/>
+            <p:nvPr/>
+          </p:nvSpPr>
+          <p:spPr>
+            <a:xfrm>
+              <a:off x="1879854" y="4766310"/>
+              <a:ext cx="2435352" cy="234696"/>
+            </a:xfrm>
+            <a:prstGeom prst="rect">
+              <a:avLst/>
+            </a:prstGeom>
+            <a:noFill/>
+            <a:ln>
+              <a:noFill/>
+            </a:ln>
+          </p:spPr>
+          <p:txBody>
+            <a:bodyPr wrap="none" lIns="0" tIns="0" rIns="0" bIns="0" anchor="t" anchorCtr="0">
+              <a:spAutoFit/>
+            </a:bodyPr>
+            <a:lstStyle/>
+            <a:p>
+              <a:pPr algn="l"/>
+              <a:r>
+                <a:rPr lang="zh-CN" sz="1200" dirty="0">
+                  <a:solidFill>
+                    <a:schemeClr val="accent5"/>
+                  </a:solidFill>
+                  <a:latin typeface="+mn-lt"/>
+                  <a:ea typeface="+mn-ea"/>
+                  <a:cs typeface="+mn-cs"/>
+                </a:rPr>
+                <a:t>同一联合建模框架，不同分布假设</a:t>
+              </a:r>
+            </a:p>
+          </p:txBody>
+        </p:sp>
+        <p:sp>
+          <p:nvSpPr>
+            <p:cNvPr id="45" name="Line 45"/>
+            <p:cNvSpPr/>
+            <p:nvPr/>
+          </p:nvSpPr>
+          <p:spPr>
+            <a:xfrm>
+              <a:off x="4286250" y="4486275"/>
+              <a:ext cx="361950" cy="9525"/>
+            </a:xfrm>
+            <a:custGeom>
+              <a:avLst/>
+              <a:gdLst/>
+              <a:ahLst/>
+              <a:cxnLst/>
+              <a:rect l="l" t="t" r="r" b="b"/>
+              <a:pathLst>
+                <a:path w="361950" h="9525">
+                  <a:moveTo>
+                    <a:pt x="0" y="0"/>
+                  </a:moveTo>
+                  <a:lnTo>
+                    <a:pt x="361950" y="0"/>
+                  </a:lnTo>
+                </a:path>
+              </a:pathLst>
+            </a:custGeom>
+            <a:noFill/>
+            <a:ln w="28575">
+              <a:solidFill>
+                <a:schemeClr val="accent3"/>
+              </a:solidFill>
+            </a:ln>
+          </p:spPr>
+        </p:sp>
+        <p:sp>
+          <p:nvSpPr>
+            <p:cNvPr id="46" name="Freeform 46"/>
+            <p:cNvSpPr/>
+            <p:nvPr/>
+          </p:nvSpPr>
+          <p:spPr>
+            <a:xfrm>
+              <a:off x="4552950" y="4419600"/>
+              <a:ext cx="95250" cy="133350"/>
+            </a:xfrm>
+            <a:custGeom>
+              <a:avLst/>
+              <a:gdLst/>
+              <a:ahLst/>
+              <a:cxnLst/>
+              <a:rect l="l" t="t" r="r" b="b"/>
+              <a:pathLst>
+                <a:path w="95250" h="133350">
+                  <a:moveTo>
+                    <a:pt x="95250" y="66675"/>
+                  </a:moveTo>
+                  <a:lnTo>
+                    <a:pt x="0" y="0"/>
+                  </a:lnTo>
+                  <a:lnTo>
+                    <a:pt x="0" y="133350"/>
+                  </a:lnTo>
+                  <a:close/>
+                </a:path>
+              </a:pathLst>
+            </a:custGeom>
+            <a:solidFill>
+              <a:schemeClr val="accent3"/>
+            </a:solidFill>
+            <a:ln>
+              <a:noFill/>
+            </a:ln>
+          </p:spPr>
+        </p:sp>
+        <p:sp>
+          <p:nvSpPr>
+            <p:cNvPr id="47" name="Rectangle 47"/>
+            <p:cNvSpPr/>
+            <p:nvPr/>
+          </p:nvSpPr>
+          <p:spPr>
+            <a:xfrm>
+              <a:off x="4724400" y="3810000"/>
+              <a:ext cx="2628900" cy="1352550"/>
+            </a:xfrm>
+            <a:prstGeom prst="roundRect">
+              <a:avLst>
+                <a:gd name="adj" fmla="val 12676"/>
+              </a:avLst>
+            </a:prstGeom>
+            <a:solidFill>
+              <a:schemeClr val="lt2"/>
+            </a:solidFill>
+            <a:ln>
+              <a:noFill/>
+            </a:ln>
+          </p:spPr>
+        </p:sp>
+        <p:sp>
+          <p:nvSpPr>
+            <p:cNvPr id="48" name="Ellipse 48"/>
+            <p:cNvSpPr/>
+            <p:nvPr/>
+          </p:nvSpPr>
+          <p:spPr>
+            <a:xfrm>
+              <a:off x="4857750" y="3943350"/>
+              <a:ext cx="342900" cy="342900"/>
+            </a:xfrm>
+            <a:prstGeom prst="ellipse">
+              <a:avLst/>
+            </a:prstGeom>
+            <a:solidFill>
+              <a:schemeClr val="accent2"/>
+            </a:solidFill>
+            <a:ln>
+              <a:noFill/>
+            </a:ln>
+          </p:spPr>
+        </p:sp>
+        <p:sp>
+          <p:nvSpPr>
+            <p:cNvPr id="49" name="TextBox 49"/>
+            <p:cNvSpPr txBox="1"/>
+            <p:nvPr/>
+          </p:nvSpPr>
+          <p:spPr>
+            <a:xfrm>
+              <a:off x="4934255" y="4051935"/>
+              <a:ext cx="189890" cy="234696"/>
+            </a:xfrm>
+            <a:prstGeom prst="rect">
+              <a:avLst/>
+            </a:prstGeom>
+            <a:noFill/>
+            <a:ln>
+              <a:noFill/>
+            </a:ln>
+          </p:spPr>
+          <p:txBody>
+            <a:bodyPr wrap="none" lIns="0" tIns="0" rIns="0" bIns="0" anchor="t" anchorCtr="0">
+              <a:spAutoFit/>
+            </a:bodyPr>
+            <a:lstStyle/>
+            <a:p>
+              <a:pPr algn="ctr"/>
+              <a:r>
+                <a:rPr lang="zh-CN" sz="1200" dirty="0">
+                  <a:solidFill>
+                    <a:srgbClr val="FFFFFF"/>
+                  </a:solidFill>
+                  <a:latin typeface="+mn-lt"/>
+                  <a:ea typeface="+mn-ea"/>
+                  <a:cs typeface="+mn-cs"/>
+                </a:rPr>
+                <a:t>06</a:t>
+              </a:r>
+            </a:p>
+          </p:txBody>
+        </p:sp>
+        <p:sp>
+          <p:nvSpPr>
+            <p:cNvPr id="50" name="TextBox 50"/>
+            <p:cNvSpPr txBox="1"/>
+            <p:nvPr/>
+          </p:nvSpPr>
+          <p:spPr>
+            <a:xfrm>
+              <a:off x="5306949" y="4001929"/>
+              <a:ext cx="1331242" cy="308039"/>
+            </a:xfrm>
+            <a:prstGeom prst="rect">
+              <a:avLst/>
+            </a:prstGeom>
+            <a:noFill/>
+            <a:ln>
+              <a:noFill/>
+            </a:ln>
+          </p:spPr>
+          <p:txBody>
+            <a:bodyPr wrap="none" lIns="0" tIns="0" rIns="0" bIns="0" anchor="t" anchorCtr="0">
+              <a:spAutoFit/>
+            </a:bodyPr>
+            <a:lstStyle/>
+            <a:p>
+              <a:pPr algn="l"/>
+              <a:r>
+                <a:rPr lang="zh-CN" sz="1580" dirty="0">
+                  <a:solidFill>
+                    <a:schemeClr val="accent1"/>
+                  </a:solidFill>
+                  <a:latin typeface="+mn-lt"/>
+                  <a:ea typeface="+mn-ea"/>
+                  <a:cs typeface="+mn-cs"/>
+                </a:rPr>
+                <a:t>Package 实现</a:t>
+              </a:r>
+            </a:p>
+          </p:txBody>
+        </p:sp>
+        <p:sp>
+          <p:nvSpPr>
+            <p:cNvPr id="51" name="TextBox 51"/>
+            <p:cNvSpPr txBox="1"/>
+            <p:nvPr/>
+          </p:nvSpPr>
+          <p:spPr>
+            <a:xfrm>
+              <a:off x="4946523" y="4434364"/>
+              <a:ext cx="2649352" cy="249364"/>
+            </a:xfrm>
+            <a:prstGeom prst="rect">
+              <a:avLst/>
+            </a:prstGeom>
+            <a:noFill/>
+            <a:ln>
+              <a:noFill/>
+            </a:ln>
+          </p:spPr>
+          <p:txBody>
+            <a:bodyPr wrap="none" lIns="0" tIns="0" rIns="0" bIns="0" anchor="t" anchorCtr="0">
+              <a:spAutoFit/>
+            </a:bodyPr>
+            <a:lstStyle/>
+            <a:p>
+              <a:pPr algn="l"/>
+              <a:r>
+                <a:rPr lang="zh-CN" sz="1280" dirty="0">
+                  <a:solidFill>
+                    <a:schemeClr val="dk1"/>
+                  </a:solidFill>
+                  <a:latin typeface="+mn-lt"/>
+                  <a:ea typeface="+mn-ea"/>
+                  <a:cs typeface="+mn-cs"/>
+                </a:rPr>
+                <a:t>配置、fit、analyze、save / load</a:t>
+              </a:r>
+            </a:p>
+          </p:txBody>
+        </p:sp>
+        <p:sp>
+          <p:nvSpPr>
+            <p:cNvPr id="52" name="TextBox 52"/>
+            <p:cNvSpPr txBox="1"/>
+            <p:nvPr/>
+          </p:nvSpPr>
+          <p:spPr>
+            <a:xfrm>
+              <a:off x="4946904" y="4766310"/>
+              <a:ext cx="2193036" cy="234696"/>
+            </a:xfrm>
+            <a:prstGeom prst="rect">
+              <a:avLst/>
+            </a:prstGeom>
+            <a:noFill/>
+            <a:ln>
+              <a:noFill/>
+            </a:ln>
+          </p:spPr>
+          <p:txBody>
+            <a:bodyPr wrap="none" lIns="0" tIns="0" rIns="0" bIns="0" anchor="t" anchorCtr="0">
+              <a:spAutoFit/>
+            </a:bodyPr>
+            <a:lstStyle/>
+            <a:p>
+              <a:pPr algn="l"/>
+              <a:r>
+                <a:rPr lang="zh-CN" sz="1200" dirty="0">
+                  <a:solidFill>
+                    <a:schemeClr val="accent5"/>
+                  </a:solidFill>
+                  <a:latin typeface="+mn-lt"/>
+                  <a:ea typeface="+mn-ea"/>
+                  <a:cs typeface="+mn-cs"/>
+                </a:rPr>
+                <a:t>输出：可复用 `.pt` artifact</a:t>
+              </a:r>
+            </a:p>
+          </p:txBody>
+        </p:sp>
+        <p:sp>
+          <p:nvSpPr>
+            <p:cNvPr id="53" name="Line 53"/>
+            <p:cNvSpPr/>
+            <p:nvPr/>
+          </p:nvSpPr>
+          <p:spPr>
+            <a:xfrm>
+              <a:off x="7353300" y="4486275"/>
+              <a:ext cx="361950" cy="9525"/>
+            </a:xfrm>
+            <a:custGeom>
+              <a:avLst/>
+              <a:gdLst/>
+              <a:ahLst/>
+              <a:cxnLst/>
+              <a:rect l="l" t="t" r="r" b="b"/>
+              <a:pathLst>
+                <a:path w="361950" h="9525">
+                  <a:moveTo>
+                    <a:pt x="0" y="0"/>
+                  </a:moveTo>
+                  <a:lnTo>
+                    <a:pt x="361950" y="0"/>
+                  </a:lnTo>
+                </a:path>
+              </a:pathLst>
+            </a:custGeom>
+            <a:noFill/>
+            <a:ln w="28575">
+              <a:solidFill>
+                <a:schemeClr val="accent3"/>
+              </a:solidFill>
+            </a:ln>
+          </p:spPr>
+        </p:sp>
+        <p:sp>
+          <p:nvSpPr>
+            <p:cNvPr id="54" name="Freeform 54"/>
+            <p:cNvSpPr/>
+            <p:nvPr/>
+          </p:nvSpPr>
+          <p:spPr>
+            <a:xfrm>
+              <a:off x="7620000" y="4419600"/>
+              <a:ext cx="95250" cy="133350"/>
+            </a:xfrm>
+            <a:custGeom>
+              <a:avLst/>
+              <a:gdLst/>
+              <a:ahLst/>
+              <a:cxnLst/>
+              <a:rect l="l" t="t" r="r" b="b"/>
+              <a:pathLst>
+                <a:path w="95250" h="133350">
+                  <a:moveTo>
+                    <a:pt x="95250" y="66675"/>
+                  </a:moveTo>
+                  <a:lnTo>
+                    <a:pt x="0" y="0"/>
+                  </a:lnTo>
+                  <a:lnTo>
+                    <a:pt x="0" y="133350"/>
+                  </a:lnTo>
+                  <a:close/>
+                </a:path>
+              </a:pathLst>
+            </a:custGeom>
+            <a:solidFill>
+              <a:schemeClr val="accent3"/>
+            </a:solidFill>
+            <a:ln>
+              <a:noFill/>
+            </a:ln>
+          </p:spPr>
+        </p:sp>
+        <p:sp>
+          <p:nvSpPr>
+            <p:cNvPr id="55" name="Rectangle 55"/>
+            <p:cNvSpPr/>
+            <p:nvPr/>
+          </p:nvSpPr>
+          <p:spPr>
+            <a:xfrm>
+              <a:off x="7791450" y="3810000"/>
+              <a:ext cx="2743200" cy="1352550"/>
+            </a:xfrm>
+            <a:prstGeom prst="roundRect">
+              <a:avLst>
+                <a:gd name="adj" fmla="val 12676"/>
+              </a:avLst>
+            </a:prstGeom>
+            <a:solidFill>
+              <a:srgbClr val="FFFFFF"/>
+            </a:solidFill>
+            <a:ln w="19050">
+              <a:solidFill>
+                <a:schemeClr val="accent6"/>
+              </a:solidFill>
+            </a:ln>
+          </p:spPr>
+        </p:sp>
+        <p:sp>
+          <p:nvSpPr>
+            <p:cNvPr id="56" name="Ellipse 56"/>
+            <p:cNvSpPr/>
+            <p:nvPr/>
+          </p:nvSpPr>
+          <p:spPr>
+            <a:xfrm>
+              <a:off x="7924800" y="3943350"/>
+              <a:ext cx="342900" cy="342900"/>
+            </a:xfrm>
+            <a:prstGeom prst="ellipse">
+              <a:avLst/>
+            </a:prstGeom>
+            <a:solidFill>
+              <a:schemeClr val="accent2"/>
+            </a:solidFill>
+            <a:ln>
+              <a:noFill/>
+            </a:ln>
+          </p:spPr>
+        </p:sp>
+        <p:sp>
+          <p:nvSpPr>
+            <p:cNvPr id="57" name="TextBox 57"/>
+            <p:cNvSpPr txBox="1"/>
+            <p:nvPr/>
+          </p:nvSpPr>
+          <p:spPr>
+            <a:xfrm>
+              <a:off x="8001305" y="4051935"/>
+              <a:ext cx="189890" cy="234696"/>
+            </a:xfrm>
+            <a:prstGeom prst="rect">
+              <a:avLst/>
+            </a:prstGeom>
+            <a:noFill/>
+            <a:ln>
+              <a:noFill/>
+            </a:ln>
+          </p:spPr>
+          <p:txBody>
+            <a:bodyPr wrap="none" lIns="0" tIns="0" rIns="0" bIns="0" anchor="t" anchorCtr="0">
+              <a:spAutoFit/>
+            </a:bodyPr>
+            <a:lstStyle/>
+            <a:p>
+              <a:pPr algn="ctr"/>
+              <a:r>
+                <a:rPr lang="zh-CN" sz="1200" dirty="0">
+                  <a:solidFill>
+                    <a:srgbClr val="FFFFFF"/>
+                  </a:solidFill>
+                  <a:latin typeface="+mn-lt"/>
+                  <a:ea typeface="+mn-ea"/>
+                  <a:cs typeface="+mn-cs"/>
+                </a:rPr>
+                <a:t>07</a:t>
+              </a:r>
+            </a:p>
+          </p:txBody>
+        </p:sp>
+        <p:sp>
+          <p:nvSpPr>
+            <p:cNvPr id="58" name="TextBox 58"/>
+            <p:cNvSpPr txBox="1"/>
+            <p:nvPr/>
+          </p:nvSpPr>
+          <p:spPr>
+            <a:xfrm>
+              <a:off x="8373999" y="4001929"/>
+              <a:ext cx="866800" cy="308039"/>
+            </a:xfrm>
+            <a:prstGeom prst="rect">
+              <a:avLst/>
+            </a:prstGeom>
+            <a:noFill/>
+            <a:ln>
+              <a:noFill/>
+            </a:ln>
+          </p:spPr>
+          <p:txBody>
+            <a:bodyPr wrap="none" lIns="0" tIns="0" rIns="0" bIns="0" anchor="t" anchorCtr="0">
+              <a:spAutoFit/>
+            </a:bodyPr>
+            <a:lstStyle/>
+            <a:p>
+              <a:pPr algn="l"/>
+              <a:r>
+                <a:rPr lang="zh-CN" sz="1580" dirty="0">
+                  <a:solidFill>
+                    <a:schemeClr val="accent1"/>
+                  </a:solidFill>
+                  <a:latin typeface="+mn-lt"/>
+                  <a:ea typeface="+mn-ea"/>
+                  <a:cs typeface="+mn-cs"/>
+                </a:rPr>
+                <a:t>复现验证</a:t>
+              </a:r>
+            </a:p>
+          </p:txBody>
+        </p:sp>
+        <p:sp>
+          <p:nvSpPr>
+            <p:cNvPr id="59" name="TextBox 59"/>
+            <p:cNvSpPr txBox="1"/>
+            <p:nvPr/>
+          </p:nvSpPr>
+          <p:spPr>
+            <a:xfrm>
+              <a:off x="8013573" y="4434364"/>
+              <a:ext cx="2123796" cy="249364"/>
+            </a:xfrm>
+            <a:prstGeom prst="rect">
+              <a:avLst/>
+            </a:prstGeom>
+            <a:noFill/>
+            <a:ln>
+              <a:noFill/>
+            </a:ln>
+          </p:spPr>
+          <p:txBody>
+            <a:bodyPr wrap="none" lIns="0" tIns="0" rIns="0" bIns="0" anchor="t" anchorCtr="0">
+              <a:spAutoFit/>
+            </a:bodyPr>
+            <a:lstStyle/>
+            <a:p>
+              <a:pPr algn="l"/>
+              <a:r>
+                <a:rPr lang="zh-CN" sz="1280" dirty="0">
+                  <a:solidFill>
+                    <a:schemeClr val="dk1"/>
+                  </a:solidFill>
+                  <a:latin typeface="+mn-lt"/>
+                  <a:ea typeface="+mn-ea"/>
+                  <a:cs typeface="+mn-cs"/>
+                </a:rPr>
+                <a:t>收敛、采样质量、moments</a:t>
+              </a:r>
+            </a:p>
+          </p:txBody>
+        </p:sp>
+        <p:sp>
+          <p:nvSpPr>
+            <p:cNvPr id="60" name="TextBox 60"/>
+            <p:cNvSpPr txBox="1"/>
+            <p:nvPr/>
+          </p:nvSpPr>
+          <p:spPr>
+            <a:xfrm>
+              <a:off x="8013954" y="4766310"/>
+              <a:ext cx="1789176" cy="234696"/>
+            </a:xfrm>
+            <a:prstGeom prst="rect">
+              <a:avLst/>
+            </a:prstGeom>
+            <a:noFill/>
+            <a:ln>
+              <a:noFill/>
+            </a:ln>
+          </p:spPr>
+          <p:txBody>
+            <a:bodyPr wrap="none" lIns="0" tIns="0" rIns="0" bIns="0" anchor="t" anchorCtr="0">
+              <a:spAutoFit/>
+            </a:bodyPr>
+            <a:lstStyle/>
+            <a:p>
+              <a:pPr algn="l"/>
+              <a:r>
+                <a:rPr lang="zh-CN" sz="1200" dirty="0">
+                  <a:solidFill>
+                    <a:schemeClr val="accent5"/>
+                  </a:solidFill>
+                  <a:latin typeface="+mn-lt"/>
+                  <a:ea typeface="+mn-ea"/>
+                  <a:cs typeface="+mn-cs"/>
+                </a:rPr>
+                <a:t>输出：可审计的复现证据</a:t>
+              </a:r>
+            </a:p>
+          </p:txBody>
+        </p:sp>
+      </p:grpSp>
+      <p:grpSp>
+        <p:nvGrpSpPr>
+          <p:cNvPr id="64" name="p02-thread"/>
+          <p:cNvGrpSpPr/>
+          <p:nvPr/>
+        </p:nvGrpSpPr>
+        <p:grpSpPr>
+          <a:xfrm>
+            <a:off x="609600" y="5467350"/>
+            <a:ext cx="10972800" cy="419100"/>
+            <a:chOff x="609600" y="5467350"/>
+            <a:chExt cx="10972800" cy="419100"/>
+          </a:xfrm>
+        </p:grpSpPr>
+        <p:sp>
+          <p:nvSpPr>
+            <p:cNvPr id="62" name="Rectangle 62"/>
+            <p:cNvSpPr/>
+            <p:nvPr/>
+          </p:nvSpPr>
+          <p:spPr>
+            <a:xfrm>
+              <a:off x="609600" y="5467350"/>
+              <a:ext cx="10972800" cy="419100"/>
+            </a:xfrm>
+            <a:prstGeom prst="roundRect">
+              <a:avLst>
+                <a:gd name="adj" fmla="val 22727"/>
+              </a:avLst>
+            </a:prstGeom>
+            <a:solidFill>
+              <a:schemeClr val="accent1"/>
+            </a:solidFill>
+            <a:ln>
+              <a:noFill/>
+            </a:ln>
+          </p:spPr>
+        </p:sp>
+        <p:sp>
+          <p:nvSpPr>
+            <p:cNvPr id="63" name="TextBox 63"/>
+            <p:cNvSpPr txBox="1"/>
+            <p:nvPr/>
+          </p:nvSpPr>
+          <p:spPr>
+            <a:xfrm>
+              <a:off x="2557094" y="5605939"/>
+              <a:ext cx="7077812" cy="249364"/>
+            </a:xfrm>
+            <a:prstGeom prst="rect">
+              <a:avLst/>
+            </a:prstGeom>
+            <a:noFill/>
+            <a:ln>
+              <a:noFill/>
+            </a:ln>
+          </p:spPr>
+          <p:txBody>
+            <a:bodyPr wrap="none" lIns="0" tIns="0" rIns="0" bIns="0" anchor="t" anchorCtr="0">
+              <a:spAutoFit/>
+            </a:bodyPr>
+            <a:lstStyle/>
+            <a:p>
+              <a:pPr algn="ctr"/>
+              <a:r>
+                <a:rPr lang="zh-CN" sz="1280" dirty="0">
+                  <a:solidFill>
+                    <a:srgbClr val="FFFFFF"/>
+                  </a:solidFill>
+                  <a:latin typeface="+mn-lt"/>
+                  <a:ea typeface="+mn-ea"/>
+                  <a:cs typeface="+mn-cs"/>
+                </a:rPr>
+                <a:t>主线问题：如何把多变量数据转化为一个可训练、可解释、可验证、可复用的联合分布模型？</a:t>
+              </a:r>
+            </a:p>
+          </p:txBody>
+        </p:sp>
+      </p:grpSp>
+      <p:grpSp>
+        <p:nvGrpSpPr>
+          <p:cNvPr id="68" name="p02-footer"/>
+          <p:cNvGrpSpPr/>
+          <p:nvPr/>
+        </p:nvGrpSpPr>
+        <p:grpSpPr>
+          <a:xfrm>
+            <a:off x="604266" y="6115050"/>
+            <a:ext cx="10983468" cy="320611"/>
+            <a:chOff x="604266" y="6115050"/>
+            <a:chExt cx="10983468" cy="320611"/>
+          </a:xfrm>
+        </p:grpSpPr>
+        <p:sp>
+          <p:nvSpPr>
+            <p:cNvPr id="65" name="Line 65"/>
+            <p:cNvSpPr/>
+            <p:nvPr/>
+          </p:nvSpPr>
+          <p:spPr>
+            <a:xfrm>
+              <a:off x="609600" y="6115050"/>
+              <a:ext cx="10972800" cy="9525"/>
+            </a:xfrm>
+            <a:custGeom>
+              <a:avLst/>
+              <a:gdLst/>
+              <a:ahLst/>
+              <a:cxnLst/>
+              <a:rect l="l" t="t" r="r" b="b"/>
+              <a:pathLst>
+                <a:path w="10972800" h="9525">
+                  <a:moveTo>
+                    <a:pt x="0" y="0"/>
+                  </a:moveTo>
+                  <a:lnTo>
+                    <a:pt x="10972800" y="0"/>
+                  </a:lnTo>
+                </a:path>
+              </a:pathLst>
+            </a:custGeom>
+            <a:noFill/>
+            <a:ln w="9525">
+              <a:solidFill>
+                <a:schemeClr val="accent6"/>
+              </a:solidFill>
+            </a:ln>
+          </p:spPr>
+        </p:sp>
+        <p:sp>
+          <p:nvSpPr>
+            <p:cNvPr id="66" name="TextBox 66"/>
+            <p:cNvSpPr txBox="1"/>
+            <p:nvPr/>
+          </p:nvSpPr>
+          <p:spPr>
+            <a:xfrm>
+              <a:off x="604266" y="6230302"/>
+              <a:ext cx="1934108" cy="205359"/>
+            </a:xfrm>
+            <a:prstGeom prst="rect">
+              <a:avLst/>
+            </a:prstGeom>
+            <a:noFill/>
+            <a:ln>
+              <a:noFill/>
+            </a:ln>
+          </p:spPr>
+          <p:txBody>
+            <a:bodyPr wrap="none" lIns="0" tIns="0" rIns="0" bIns="0" anchor="t" anchorCtr="0">
+              <a:spAutoFit/>
+            </a:bodyPr>
+            <a:lstStyle/>
+            <a:p>
+              <a:pPr algn="l"/>
+              <a:r>
+                <a:rPr lang="zh-CN" sz="1050" dirty="0">
+                  <a:solidFill>
+                    <a:schemeClr val="accent5"/>
+                  </a:solidFill>
+                  <a:latin typeface="+mn-lt"/>
+                  <a:ea typeface="+mn-ea"/>
+                  <a:cs typeface="+mn-cs"/>
+                </a:rPr>
+                <a:t>LEARNENERGY · 技术主线总览</a:t>
+              </a:r>
+            </a:p>
+          </p:txBody>
+        </p:sp>
+        <p:sp>
+          <p:nvSpPr>
+            <p:cNvPr id="67" name="TextBox 67"/>
+            <p:cNvSpPr txBox="1"/>
+            <p:nvPr/>
+          </p:nvSpPr>
+          <p:spPr>
+            <a:xfrm>
+              <a:off x="11103540" y="6230302"/>
+              <a:ext cx="484194" cy="205359"/>
+            </a:xfrm>
+            <a:prstGeom prst="rect">
+              <a:avLst/>
+            </a:prstGeom>
+            <a:noFill/>
+            <a:ln>
+              <a:noFill/>
+            </a:ln>
+          </p:spPr>
+          <p:txBody>
+            <a:bodyPr wrap="none" lIns="0" tIns="0" rIns="0" bIns="0" anchor="t" anchorCtr="0">
+              <a:spAutoFit/>
+            </a:bodyPr>
+            <a:lstStyle/>
+            <a:p>
+              <a:pPr algn="r"/>
+              <a:r>
+                <a:rPr lang="zh-CN" sz="1050" dirty="0">
+                  <a:solidFill>
+                    <a:schemeClr val="accent5"/>
+                  </a:solidFill>
+                  <a:latin typeface="+mn-lt"/>
+                  <a:ea typeface="+mn-ea"/>
+                  <a:cs typeface="+mn-cs"/>
+                </a:rPr>
+                <a:t>02 / 30</a:t>
+              </a:r>
+            </a:p>
+          </p:txBody>
+        </p:sp>
+      </p:grpSp>
     </p:spTree>
   </p:cSld>
   <p:clrMapOvr>
@@ -17409,7 +18780,7 @@
           <p:spPr>
             <a:xfrm>
               <a:off x="603504" y="556260"/>
-              <a:ext cx="658368" cy="234696"/>
+              <a:ext cx="1878025" cy="234696"/>
             </a:xfrm>
             <a:prstGeom prst="rect">
               <a:avLst/>
@@ -17435,7 +18806,7 @@
                   <a:ea typeface="+mn-ea"/>
                   <a:cs typeface="+mn-cs"/>
                 </a:rPr>
-                <a:t>选择指南</a:t>
+                <a:t>技术主线 · 03 计算与训练</a:t>
               </a:r>
             </a:p>
           </p:txBody>
@@ -18597,7 +19968,7 @@
         <p:spPr>
           <a:xfrm>
             <a:off x="604266" y="6516052"/>
-            <a:ext cx="3685794" cy="205359"/>
+            <a:ext cx="3728199" cy="205359"/>
           </a:xfrm>
           <a:prstGeom prst="rect">
             <a:avLst/>
@@ -18623,7 +19994,7 @@
                 <a:ea typeface="+mn-ea"/>
                 <a:cs typeface="+mn-cs"/>
               </a:rPr>
-              <a:t>20 / 30 · auto 适合一般调用；科研报告必须记录实际选择</a:t>
+              <a:t>本阶段输出：训练配置 + 拟合参数 → 下一阶段：解释与诊断</a:t>
             </a:r>
           </a:p>
         </p:txBody>
@@ -18687,7 +20058,7 @@
           <p:spPr>
             <a:xfrm>
               <a:off x="603504" y="556260"/>
-              <a:ext cx="658368" cy="234696"/>
+              <a:ext cx="1878025" cy="234696"/>
             </a:xfrm>
             <a:prstGeom prst="rect">
               <a:avLst/>
@@ -18713,7 +20084,7 @@
                   <a:ea typeface="+mn-ea"/>
                   <a:cs typeface="+mn-cs"/>
                 </a:rPr>
-                <a:t>可解释性</a:t>
+                <a:t>技术主线 · 04 解释与诊断</a:t>
               </a:r>
             </a:p>
           </p:txBody>
@@ -19725,7 +21096,7 @@
           <p:spPr>
             <a:xfrm>
               <a:off x="603504" y="556260"/>
-              <a:ext cx="819912" cy="234696"/>
+              <a:ext cx="1878025" cy="234696"/>
             </a:xfrm>
             <a:prstGeom prst="rect">
               <a:avLst/>
@@ -19751,7 +21122,7 @@
                   <a:ea typeface="+mn-ea"/>
                   <a:cs typeface="+mn-cs"/>
                 </a:rPr>
-                <a:t>敏感性诊断</a:t>
+                <a:t>技术主线 · 04 解释与诊断</a:t>
               </a:r>
             </a:p>
           </p:txBody>
@@ -20449,7 +21820,7 @@
         <p:spPr>
           <a:xfrm>
             <a:off x="604266" y="6516052"/>
-            <a:ext cx="5191182" cy="205359"/>
+            <a:ext cx="4152252" cy="205359"/>
           </a:xfrm>
           <a:prstGeom prst="rect">
             <a:avLst/>
@@ -20475,7 +21846,7 @@
                 <a:ea typeface="+mn-ea"/>
                 <a:cs typeface="+mn-cs"/>
               </a:rPr>
-              <a:t>22 / 30 · temperature_response 使用 exact states，避免把采样噪声误认成峰</a:t>
+              <a:t>本阶段输出：模型内解释 + 敏感性边界 → 下一阶段：连续变量模型</a:t>
             </a:r>
           </a:p>
         </p:txBody>
@@ -20539,7 +21910,7 @@
           <p:spPr>
             <a:xfrm>
               <a:off x="603504" y="651510"/>
-              <a:ext cx="819912" cy="234696"/>
+              <a:ext cx="1716481" cy="234696"/>
             </a:xfrm>
             <a:prstGeom prst="rect">
               <a:avLst/>
@@ -20565,7 +21936,7 @@
                   <a:ea typeface="+mn-ea"/>
                   <a:cs typeface="+mn-cs"/>
                 </a:rPr>
-                <a:t>第二类模型</a:t>
+                <a:t>技术主线 · 05 连续模型</a:t>
               </a:r>
             </a:p>
           </p:txBody>
@@ -21289,7 +22660,7 @@
           <p:spPr>
             <a:xfrm>
               <a:off x="603504" y="556260"/>
-              <a:ext cx="1490320" cy="234696"/>
+              <a:ext cx="1716481" cy="234696"/>
             </a:xfrm>
             <a:prstGeom prst="rect">
               <a:avLst/>
@@ -21315,7 +22686,7 @@
                   <a:ea typeface="+mn-ea"/>
                   <a:cs typeface="+mn-cs"/>
                 </a:rPr>
-                <a:t>连续模型 · 核心公式</a:t>
+                <a:t>技术主线 · 05 连续模型</a:t>
               </a:r>
             </a:p>
           </p:txBody>
@@ -22125,7 +23496,7 @@
           <p:spPr>
             <a:xfrm>
               <a:off x="603504" y="556260"/>
-              <a:ext cx="1490320" cy="234696"/>
+              <a:ext cx="1716481" cy="234696"/>
             </a:xfrm>
             <a:prstGeom prst="rect">
               <a:avLst/>
@@ -22151,7 +23522,7 @@
                   <a:ea typeface="+mn-ea"/>
                   <a:cs typeface="+mn-cs"/>
                 </a:rPr>
-                <a:t>连续模型 · 条件推断</a:t>
+                <a:t>技术主线 · 05 连续模型</a:t>
               </a:r>
             </a:p>
           </p:txBody>
@@ -22937,7 +24308,7 @@
         <p:spPr>
           <a:xfrm>
             <a:off x="604266" y="6516052"/>
-            <a:ext cx="4427887" cy="205359"/>
+            <a:ext cx="4178198" cy="205359"/>
           </a:xfrm>
           <a:prstGeom prst="rect">
             <a:avLst/>
@@ -22963,7 +24334,7 @@
                 <a:ea typeface="+mn-ea"/>
                 <a:cs typeface="+mn-cs"/>
               </a:rPr>
-              <a:t>25 / 30 · 边界：当前连续模型不覆盖 mixed-node、非线性或重尾分布</a:t>
+              <a:t>本阶段输出：连续联合模型 + 条件查询 → 下一阶段：Package 实现</a:t>
             </a:r>
           </a:p>
         </p:txBody>
@@ -23027,7 +24398,7 @@
           <p:spPr>
             <a:xfrm>
               <a:off x="603504" y="556260"/>
-              <a:ext cx="658368" cy="234696"/>
+              <a:ext cx="2125066" cy="234696"/>
             </a:xfrm>
             <a:prstGeom prst="rect">
               <a:avLst/>
@@ -23053,7 +24424,7 @@
                   <a:ea typeface="+mn-ea"/>
                   <a:cs typeface="+mn-cs"/>
                 </a:rPr>
-                <a:t>软件架构</a:t>
+                <a:t>技术主线 · 06 PACKAGE 实现</a:t>
               </a:r>
             </a:p>
           </p:txBody>
@@ -23801,7 +25172,7 @@
           <p:spPr>
             <a:xfrm>
               <a:off x="603504" y="556260"/>
-              <a:ext cx="1457401" cy="234696"/>
+              <a:ext cx="2125066" cy="234696"/>
             </a:xfrm>
             <a:prstGeom prst="rect">
               <a:avLst/>
@@ -23827,7 +25198,7 @@
                   <a:ea typeface="+mn-ea"/>
                   <a:cs typeface="+mn-cs"/>
                 </a:rPr>
-                <a:t>API 示例 · 二值模型</a:t>
+                <a:t>技术主线 · 06 PACKAGE 实现</a:t>
               </a:r>
             </a:p>
           </p:txBody>
@@ -24973,7 +26344,7 @@
           <p:spPr>
             <a:xfrm>
               <a:off x="603504" y="556260"/>
-              <a:ext cx="1457401" cy="234696"/>
+              <a:ext cx="2125066" cy="234696"/>
             </a:xfrm>
             <a:prstGeom prst="rect">
               <a:avLst/>
@@ -24999,7 +26370,7 @@
                   <a:ea typeface="+mn-ea"/>
                   <a:cs typeface="+mn-cs"/>
                 </a:rPr>
-                <a:t>API 示例 · 连续模型</a:t>
+                <a:t>技术主线 · 06 PACKAGE 实现</a:t>
               </a:r>
             </a:p>
           </p:txBody>
@@ -25961,7 +27332,7 @@
         <p:spPr>
           <a:xfrm>
             <a:off x="604266" y="6516052"/>
-            <a:ext cx="3191066" cy="205359"/>
+            <a:ext cx="4074509" cy="205359"/>
           </a:xfrm>
           <a:prstGeom prst="rect">
             <a:avLst/>
@@ -25987,7 +27358,7 @@
                 <a:ea typeface="+mn-ea"/>
                 <a:cs typeface="+mn-cs"/>
               </a:rPr>
-              <a:t>28 / 30 · 同一联合模型可对不同变量执行条件查询</a:t>
+              <a:t>本阶段输出：可复用调用 + 模型 artifact → 下一阶段：复现验证</a:t>
             </a:r>
           </a:p>
         </p:txBody>
@@ -26051,7 +27422,7 @@
           <p:spPr>
             <a:xfrm>
               <a:off x="603504" y="518160"/>
-              <a:ext cx="1614221" cy="234696"/>
+              <a:ext cx="1716481" cy="234696"/>
             </a:xfrm>
             <a:prstGeom prst="rect">
               <a:avLst/>
@@ -26077,7 +27448,7 @@
                   <a:ea typeface="+mn-ea"/>
                   <a:cs typeface="+mn-cs"/>
                 </a:rPr>
-                <a:t>PISA 2018 · 复现验证</a:t>
+                <a:t>技术主线 · 07 复现验证</a:t>
               </a:r>
             </a:p>
           </p:txBody>
@@ -26880,7 +28251,7 @@
           <p:spPr>
             <a:xfrm>
               <a:off x="603504" y="556260"/>
-              <a:ext cx="932993" cy="234696"/>
+              <a:ext cx="1716481" cy="234696"/>
             </a:xfrm>
             <a:prstGeom prst="rect">
               <a:avLst/>
@@ -26906,7 +28277,7 @@
                   <a:ea typeface="+mn-ea"/>
                   <a:cs typeface="+mn-cs"/>
                 </a:rPr>
-                <a:t>概率基础 · 1</a:t>
+                <a:t>技术主线 · 01 概率表示</a:t>
               </a:r>
             </a:p>
           </p:txBody>
@@ -27940,7 +29311,7 @@
           <p:spPr>
             <a:xfrm>
               <a:off x="603504" y="518160"/>
-              <a:ext cx="335280" cy="234696"/>
+              <a:ext cx="1716481" cy="234696"/>
             </a:xfrm>
             <a:prstGeom prst="rect">
               <a:avLst/>
@@ -27966,7 +29337,7 @@
                   <a:ea typeface="+mn-ea"/>
                   <a:cs typeface="+mn-cs"/>
                 </a:rPr>
-                <a:t>结论</a:t>
+                <a:t>技术主线 · 07 复现验证</a:t>
               </a:r>
             </a:p>
           </p:txBody>
@@ -28125,7 +29496,7 @@
       </p:grpSp>
       <p:grpSp>
         <p:nvGrpSpPr>
-          <p:cNvPr id="21" name="p30-summary"/>
+          <p:cNvPr id="23" name="p30-summary"/>
           <p:cNvGrpSpPr/>
           <p:nvPr/>
         </p:nvGrpSpPr>
@@ -28185,26 +29556,26 @@
           </p:nvSpPr>
           <p:spPr>
             <a:xfrm>
-              <a:off x="7841361" y="2017871"/>
-              <a:ext cx="2136358" cy="278702"/>
-            </a:xfrm>
-            <a:prstGeom prst="rect">
-              <a:avLst/>
-            </a:prstGeom>
-            <a:noFill/>
-            <a:ln>
-              <a:noFill/>
-            </a:ln>
-          </p:spPr>
-          <p:txBody>
-            <a:bodyPr wrap="none" lIns="0" tIns="0" rIns="0" bIns="0" anchor="t" anchorCtr="0">
-              <a:spAutoFit/>
-            </a:bodyPr>
-            <a:lstStyle/>
-            <a:p>
-              <a:pPr algn="l"/>
-              <a:r>
-                <a:rPr lang="zh-CN" sz="1420" dirty="0">
+              <a:off x="7842123" y="1900714"/>
+              <a:ext cx="1064067" cy="249364"/>
+            </a:xfrm>
+            <a:prstGeom prst="rect">
+              <a:avLst/>
+            </a:prstGeom>
+            <a:noFill/>
+            <a:ln>
+              <a:noFill/>
+            </a:ln>
+          </p:spPr>
+          <p:txBody>
+            <a:bodyPr wrap="none" lIns="0" tIns="0" rIns="0" bIns="0" anchor="t" anchorCtr="0">
+              <a:spAutoFit/>
+            </a:bodyPr>
+            <a:lstStyle/>
+            <a:p>
+              <a:pPr algn="l"/>
+              <a:r>
+                <a:rPr lang="zh-CN" sz="1280" dirty="0">
                   <a:solidFill>
                     <a:srgbClr val="FFFFFF"/>
                   </a:solidFill>
@@ -28212,7 +29583,7 @@
                   <a:ea typeface="+mn-ea"/>
                   <a:cs typeface="+mn-cs"/>
                 </a:rPr>
-                <a:t>01　定义变量与状态空间</a:t>
+                <a:t>01　概率表示</a:t>
               </a:r>
             </a:p>
           </p:txBody>
@@ -28225,26 +29596,26 @@
           </p:nvSpPr>
           <p:spPr>
             <a:xfrm>
-              <a:off x="7841361" y="2436971"/>
-              <a:ext cx="2799396" cy="278702"/>
-            </a:xfrm>
-            <a:prstGeom prst="rect">
-              <a:avLst/>
-            </a:prstGeom>
-            <a:noFill/>
-            <a:ln>
-              <a:noFill/>
-            </a:ln>
-          </p:spPr>
-          <p:txBody>
-            <a:bodyPr wrap="none" lIns="0" tIns="0" rIns="0" bIns="0" anchor="t" anchorCtr="0">
-              <a:spAutoFit/>
-            </a:bodyPr>
-            <a:lstStyle/>
-            <a:p>
-              <a:pPr algn="l"/>
-              <a:r>
-                <a:rPr lang="zh-CN" sz="1420" dirty="0">
+              <a:off x="7842123" y="2243614"/>
+              <a:ext cx="1064067" cy="249364"/>
+            </a:xfrm>
+            <a:prstGeom prst="rect">
+              <a:avLst/>
+            </a:prstGeom>
+            <a:noFill/>
+            <a:ln>
+              <a:noFill/>
+            </a:ln>
+          </p:spPr>
+          <p:txBody>
+            <a:bodyPr wrap="none" lIns="0" tIns="0" rIns="0" bIns="0" anchor="t" anchorCtr="0">
+              <a:spAutoFit/>
+            </a:bodyPr>
+            <a:lstStyle/>
+            <a:p>
+              <a:pPr algn="l"/>
+              <a:r>
+                <a:rPr lang="zh-CN" sz="1280" dirty="0">
                   <a:solidFill>
                     <a:srgbClr val="FFFFFF"/>
                   </a:solidFill>
@@ -28252,7 +29623,7 @@
                   <a:ea typeface="+mn-ea"/>
                   <a:cs typeface="+mn-cs"/>
                 </a:rPr>
-                <a:t>02　选择 exact 或 Monte Carlo</a:t>
+                <a:t>02　模型定义</a:t>
               </a:r>
             </a:p>
           </p:txBody>
@@ -28265,26 +29636,26 @@
           </p:nvSpPr>
           <p:spPr>
             <a:xfrm>
-              <a:off x="7841361" y="2856071"/>
-              <a:ext cx="1945198" cy="278702"/>
-            </a:xfrm>
-            <a:prstGeom prst="rect">
-              <a:avLst/>
-            </a:prstGeom>
-            <a:noFill/>
-            <a:ln>
-              <a:noFill/>
-            </a:ln>
-          </p:spPr>
-          <p:txBody>
-            <a:bodyPr wrap="none" lIns="0" tIns="0" rIns="0" bIns="0" anchor="t" anchorCtr="0">
-              <a:spAutoFit/>
-            </a:bodyPr>
-            <a:lstStyle/>
-            <a:p>
-              <a:pPr algn="l"/>
-              <a:r>
-                <a:rPr lang="zh-CN" sz="1420" dirty="0">
+              <a:off x="7842123" y="2586514"/>
+              <a:ext cx="1236381" cy="249364"/>
+            </a:xfrm>
+            <a:prstGeom prst="rect">
+              <a:avLst/>
+            </a:prstGeom>
+            <a:noFill/>
+            <a:ln>
+              <a:noFill/>
+            </a:ln>
+          </p:spPr>
+          <p:txBody>
+            <a:bodyPr wrap="none" lIns="0" tIns="0" rIns="0" bIns="0" anchor="t" anchorCtr="0">
+              <a:spAutoFit/>
+            </a:bodyPr>
+            <a:lstStyle/>
+            <a:p>
+              <a:pPr algn="l"/>
+              <a:r>
+                <a:rPr lang="zh-CN" sz="1280" dirty="0">
                   <a:solidFill>
                     <a:srgbClr val="FFFFFF"/>
                   </a:solidFill>
@@ -28292,7 +29663,7 @@
                   <a:ea typeface="+mn-ea"/>
                   <a:cs typeface="+mn-cs"/>
                 </a:rPr>
-                <a:t>03　选择训练更新方法</a:t>
+                <a:t>03　计算与训练</a:t>
               </a:r>
             </a:p>
           </p:txBody>
@@ -28305,26 +29676,26 @@
           </p:nvSpPr>
           <p:spPr>
             <a:xfrm>
-              <a:off x="7841361" y="3275171"/>
-              <a:ext cx="2681166" cy="278702"/>
-            </a:xfrm>
-            <a:prstGeom prst="rect">
-              <a:avLst/>
-            </a:prstGeom>
-            <a:noFill/>
-            <a:ln>
-              <a:noFill/>
-            </a:ln>
-          </p:spPr>
-          <p:txBody>
-            <a:bodyPr wrap="none" lIns="0" tIns="0" rIns="0" bIns="0" anchor="t" anchorCtr="0">
-              <a:spAutoFit/>
-            </a:bodyPr>
-            <a:lstStyle/>
-            <a:p>
-              <a:pPr algn="l"/>
-              <a:r>
-                <a:rPr lang="zh-CN" sz="1420" dirty="0">
+              <a:off x="7842123" y="2929414"/>
+              <a:ext cx="1236381" cy="249364"/>
+            </a:xfrm>
+            <a:prstGeom prst="rect">
+              <a:avLst/>
+            </a:prstGeom>
+            <a:noFill/>
+            <a:ln>
+              <a:noFill/>
+            </a:ln>
+          </p:spPr>
+          <p:txBody>
+            <a:bodyPr wrap="none" lIns="0" tIns="0" rIns="0" bIns="0" anchor="t" anchorCtr="0">
+              <a:spAutoFit/>
+            </a:bodyPr>
+            <a:lstStyle/>
+            <a:p>
+              <a:pPr algn="l"/>
+              <a:r>
+                <a:rPr lang="zh-CN" sz="1280" dirty="0">
                   <a:solidFill>
                     <a:srgbClr val="FFFFFF"/>
                   </a:solidFill>
@@ -28332,7 +29703,7 @@
                   <a:ea typeface="+mn-ea"/>
                   <a:cs typeface="+mn-cs"/>
                 </a:rPr>
-                <a:t>04　验证 moments 与诊断指标</a:t>
+                <a:t>04　解释与诊断</a:t>
               </a:r>
             </a:p>
           </p:txBody>
@@ -28345,26 +29716,26 @@
           </p:nvSpPr>
           <p:spPr>
             <a:xfrm>
-              <a:off x="7841361" y="3694271"/>
-              <a:ext cx="2977464" cy="278702"/>
-            </a:xfrm>
-            <a:prstGeom prst="rect">
-              <a:avLst/>
-            </a:prstGeom>
-            <a:noFill/>
-            <a:ln>
-              <a:noFill/>
-            </a:ln>
-          </p:spPr>
-          <p:txBody>
-            <a:bodyPr wrap="none" lIns="0" tIns="0" rIns="0" bIns="0" anchor="t" anchorCtr="0">
-              <a:spAutoFit/>
-            </a:bodyPr>
-            <a:lstStyle/>
-            <a:p>
-              <a:pPr algn="l"/>
-              <a:r>
-                <a:rPr lang="zh-CN" sz="1420" dirty="0">
+              <a:off x="7842123" y="3272314"/>
+              <a:ext cx="1408694" cy="249364"/>
+            </a:xfrm>
+            <a:prstGeom prst="rect">
+              <a:avLst/>
+            </a:prstGeom>
+            <a:noFill/>
+            <a:ln>
+              <a:noFill/>
+            </a:ln>
+          </p:spPr>
+          <p:txBody>
+            <a:bodyPr wrap="none" lIns="0" tIns="0" rIns="0" bIns="0" anchor="t" anchorCtr="0">
+              <a:spAutoFit/>
+            </a:bodyPr>
+            <a:lstStyle/>
+            <a:p>
+              <a:pPr algn="l"/>
+              <a:r>
+                <a:rPr lang="zh-CN" sz="1280" dirty="0">
                   <a:solidFill>
                     <a:srgbClr val="FFFFFF"/>
                   </a:solidFill>
@@ -28372,14 +29743,94 @@
                   <a:ea typeface="+mn-ea"/>
                   <a:cs typeface="+mn-cs"/>
                 </a:rPr>
-                <a:t>05　解释结果并保存 .pt artifact</a:t>
-              </a:r>
-            </a:p>
-          </p:txBody>
-        </p:sp>
-        <p:sp>
-          <p:nvSpPr>
-            <p:cNvPr id="16" name="Line 16"/>
+                <a:t>05　连续模型扩展</a:t>
+              </a:r>
+            </a:p>
+          </p:txBody>
+        </p:sp>
+        <p:sp>
+          <p:nvSpPr>
+            <p:cNvPr id="16" name="TextBox 16"/>
+            <p:cNvSpPr txBox="1"/>
+            <p:nvPr/>
+          </p:nvSpPr>
+          <p:spPr>
+            <a:xfrm>
+              <a:off x="7842123" y="3615214"/>
+              <a:ext cx="2379433" cy="249364"/>
+            </a:xfrm>
+            <a:prstGeom prst="rect">
+              <a:avLst/>
+            </a:prstGeom>
+            <a:noFill/>
+            <a:ln>
+              <a:noFill/>
+            </a:ln>
+          </p:spPr>
+          <p:txBody>
+            <a:bodyPr wrap="none" lIns="0" tIns="0" rIns="0" bIns="0" anchor="t" anchorCtr="0">
+              <a:spAutoFit/>
+            </a:bodyPr>
+            <a:lstStyle/>
+            <a:p>
+              <a:pPr algn="l"/>
+              <a:r>
+                <a:rPr lang="zh-CN" sz="1280" dirty="0">
+                  <a:solidFill>
+                    <a:srgbClr val="FFFFFF"/>
+                  </a:solidFill>
+                  <a:latin typeface="+mn-lt"/>
+                  <a:ea typeface="+mn-ea"/>
+                  <a:cs typeface="+mn-cs"/>
+                </a:rPr>
+                <a:t>06　Package 实现与 artifact</a:t>
+              </a:r>
+            </a:p>
+          </p:txBody>
+        </p:sp>
+        <p:sp>
+          <p:nvSpPr>
+            <p:cNvPr id="17" name="TextBox 17"/>
+            <p:cNvSpPr txBox="1"/>
+            <p:nvPr/>
+          </p:nvSpPr>
+          <p:spPr>
+            <a:xfrm>
+              <a:off x="7842123" y="3958114"/>
+              <a:ext cx="1064067" cy="249364"/>
+            </a:xfrm>
+            <a:prstGeom prst="rect">
+              <a:avLst/>
+            </a:prstGeom>
+            <a:noFill/>
+            <a:ln>
+              <a:noFill/>
+            </a:ln>
+          </p:spPr>
+          <p:txBody>
+            <a:bodyPr wrap="none" lIns="0" tIns="0" rIns="0" bIns="0" anchor="t" anchorCtr="0">
+              <a:spAutoFit/>
+            </a:bodyPr>
+            <a:lstStyle/>
+            <a:p>
+              <a:pPr algn="l"/>
+              <a:r>
+                <a:rPr lang="zh-CN" sz="1280" dirty="0">
+                  <a:solidFill>
+                    <a:srgbClr val="FFFFFF"/>
+                  </a:solidFill>
+                  <a:latin typeface="+mn-lt"/>
+                  <a:ea typeface="+mn-ea"/>
+                  <a:cs typeface="+mn-cs"/>
+                </a:rPr>
+                <a:t>07　复现验证</a:t>
+              </a:r>
+            </a:p>
+          </p:txBody>
+        </p:sp>
+        <p:sp>
+          <p:nvSpPr>
+            <p:cNvPr id="18" name="Line 18"/>
             <p:cNvSpPr/>
             <p:nvPr/>
           </p:nvSpPr>
@@ -28415,7 +29866,7 @@
         </p:sp>
         <p:sp>
           <p:nvSpPr>
-            <p:cNvPr id="17" name="TextBox 17"/>
+            <p:cNvPr id="19" name="TextBox 19"/>
             <p:cNvSpPr txBox="1"/>
             <p:nvPr/>
           </p:nvSpPr>
@@ -28455,7 +29906,7 @@
         </p:sp>
         <p:sp>
           <p:nvSpPr>
-            <p:cNvPr id="18" name="TextBox 18"/>
+            <p:cNvPr id="20" name="TextBox 20"/>
             <p:cNvSpPr txBox="1"/>
             <p:nvPr/>
           </p:nvSpPr>
@@ -28495,7 +29946,7 @@
         </p:sp>
         <p:sp>
           <p:nvSpPr>
-            <p:cNvPr id="19" name="TextBox 19"/>
+            <p:cNvPr id="21" name="TextBox 21"/>
             <p:cNvSpPr txBox="1"/>
             <p:nvPr/>
           </p:nvSpPr>
@@ -28535,7 +29986,7 @@
         </p:sp>
         <p:sp>
           <p:nvSpPr>
-            <p:cNvPr id="20" name="TextBox 20"/>
+            <p:cNvPr id="22" name="TextBox 22"/>
             <p:cNvSpPr txBox="1"/>
             <p:nvPr/>
           </p:nvSpPr>
@@ -28576,7 +30027,7 @@
       </p:grpSp>
       <p:sp>
         <p:nvSpPr>
-          <p:cNvPr id="22" name="TextBox 22"/>
+          <p:cNvPr id="24" name="TextBox 24"/>
           <p:cNvSpPr txBox="1"/>
           <p:nvPr/>
         </p:nvSpPr>
@@ -28673,7 +30124,7 @@
           <p:spPr>
             <a:xfrm>
               <a:off x="603504" y="556260"/>
-              <a:ext cx="932993" cy="234696"/>
+              <a:ext cx="1716481" cy="234696"/>
             </a:xfrm>
             <a:prstGeom prst="rect">
               <a:avLst/>
@@ -28699,7 +30150,7 @@
                   <a:ea typeface="+mn-ea"/>
                   <a:cs typeface="+mn-cs"/>
                 </a:rPr>
-                <a:t>概率基础 · 2</a:t>
+                <a:t>技术主线 · 01 概率表示</a:t>
               </a:r>
             </a:p>
           </p:txBody>
@@ -29960,7 +31411,7 @@
           <p:spPr>
             <a:xfrm>
               <a:off x="603504" y="556260"/>
-              <a:ext cx="658368" cy="234696"/>
+              <a:ext cx="1716481" cy="234696"/>
             </a:xfrm>
             <a:prstGeom prst="rect">
               <a:avLst/>
@@ -29986,7 +31437,7 @@
                   <a:ea typeface="+mn-ea"/>
                   <a:cs typeface="+mn-cs"/>
                 </a:rPr>
-                <a:t>解释边界</a:t>
+                <a:t>技术主线 · 01 概率表示</a:t>
               </a:r>
             </a:p>
           </p:txBody>
@@ -31093,7 +32544,7 @@
         <p:spPr>
           <a:xfrm>
             <a:off x="604266" y="6516052"/>
-            <a:ext cx="2908364" cy="205359"/>
+            <a:ext cx="4010901" cy="205359"/>
           </a:xfrm>
           <a:prstGeom prst="rect">
             <a:avLst/>
@@ -31119,7 +32570,7 @@
                 <a:ea typeface="+mn-ea"/>
                 <a:cs typeface="+mn-cs"/>
               </a:rPr>
-              <a:t>05 / 30 · 后续所有解释均限定在拟合分布内部</a:t>
+              <a:t>本阶段输出：概率关系 + 解释边界 → 下一阶段：能量模型参数化</a:t>
             </a:r>
           </a:p>
         </p:txBody>
@@ -31183,7 +32634,7 @@
           <p:spPr>
             <a:xfrm>
               <a:off x="603504" y="746760"/>
-              <a:ext cx="1651864" cy="234696"/>
+              <a:ext cx="1716481" cy="234696"/>
             </a:xfrm>
             <a:prstGeom prst="rect">
               <a:avLst/>
@@ -31209,7 +32660,7 @@
                   <a:ea typeface="+mn-ea"/>
                   <a:cs typeface="+mn-cs"/>
                 </a:rPr>
-                <a:t>能量模型 · 概率参数化</a:t>
+                <a:t>技术主线 · 02 模型定义</a:t>
               </a:r>
             </a:p>
           </p:txBody>
@@ -31871,7 +33322,7 @@
           <p:spPr>
             <a:xfrm>
               <a:off x="603504" y="556260"/>
-              <a:ext cx="1167232" cy="234696"/>
+              <a:ext cx="1716481" cy="234696"/>
             </a:xfrm>
             <a:prstGeom prst="rect">
               <a:avLst/>
@@ -31897,7 +33348,7 @@
                   <a:ea typeface="+mn-ea"/>
                   <a:cs typeface="+mn-cs"/>
                 </a:rPr>
-                <a:t>二值模型 · 输入</a:t>
+                <a:t>技术主线 · 02 模型定义</a:t>
               </a:r>
             </a:p>
           </p:txBody>
@@ -32829,7 +34280,7 @@
           <p:spPr>
             <a:xfrm>
               <a:off x="603504" y="556260"/>
-              <a:ext cx="1167232" cy="234696"/>
+              <a:ext cx="1716481" cy="234696"/>
             </a:xfrm>
             <a:prstGeom prst="rect">
               <a:avLst/>
@@ -32855,7 +34306,7 @@
                   <a:ea typeface="+mn-ea"/>
                   <a:cs typeface="+mn-cs"/>
                 </a:rPr>
-                <a:t>二值模型 · 原理</a:t>
+                <a:t>技术主线 · 02 模型定义</a:t>
               </a:r>
             </a:p>
           </p:txBody>
@@ -33654,7 +35105,7 @@
           <p:spPr>
             <a:xfrm>
               <a:off x="603504" y="556260"/>
-              <a:ext cx="1490320" cy="234696"/>
+              <a:ext cx="1716481" cy="234696"/>
             </a:xfrm>
             <a:prstGeom prst="rect">
               <a:avLst/>
@@ -33680,7 +35131,7 @@
                   <a:ea typeface="+mn-ea"/>
                   <a:cs typeface="+mn-cs"/>
                 </a:rPr>
-                <a:t>二值模型 · 核心公式</a:t>
+                <a:t>技术主线 · 02 模型定义</a:t>
               </a:r>
             </a:p>
           </p:txBody>

</xml_diff>